<commit_message>
maj cours jeudi matin indices de diversité
</commit_message>
<xml_diff>
--- a/3_mercredi/ephe-certificat-analyse-donnees-3-mercredi.pptx
+++ b/3_mercredi/ephe-certificat-analyse-donnees-3-mercredi.pptx
@@ -2,7 +2,7 @@
 <file path=ppt/presentation.xml><?xml version="1.0" encoding="utf-8"?>
 <p:presentation xmlns:a="http://schemas.openxmlformats.org/drawingml/2006/main" xmlns:r="http://schemas.openxmlformats.org/officeDocument/2006/relationships" xmlns:p="http://schemas.openxmlformats.org/presentationml/2006/main" saveSubsetFonts="1">
   <p:sldMasterIdLst>
-    <p:sldMasterId id="2147483648" r:id="rId1"/>
+    <p:sldMasterId id="2147483660" r:id="rId1"/>
   </p:sldMasterIdLst>
   <p:notesMasterIdLst>
     <p:notesMasterId r:id="rId8"/>
@@ -15,13 +15,13 @@
     <p:sldId id="387" r:id="rId6"/>
     <p:sldId id="388" r:id="rId7"/>
   </p:sldIdLst>
-  <p:sldSz cx="12192000" cy="6858000"/>
+  <p:sldSz cx="9144000" cy="6858000" type="screen4x3"/>
   <p:notesSz cx="6858000" cy="9144000"/>
   <p:defaultTextStyle>
     <a:defPPr>
-      <a:defRPr lang="fr-FR"/>
+      <a:defRPr lang="en-US"/>
     </a:defPPr>
-    <a:lvl1pPr marL="0" algn="l" defTabSz="914400" rtl="0" eaLnBrk="1" latinLnBrk="0" hangingPunct="1">
+    <a:lvl1pPr marL="0" algn="l" defTabSz="457200" rtl="0" eaLnBrk="1" latinLnBrk="0" hangingPunct="1">
       <a:defRPr sz="1800" kern="1200">
         <a:solidFill>
           <a:schemeClr val="tx1"/>
@@ -31,7 +31,7 @@
         <a:cs typeface="+mn-cs"/>
       </a:defRPr>
     </a:lvl1pPr>
-    <a:lvl2pPr marL="457200" algn="l" defTabSz="914400" rtl="0" eaLnBrk="1" latinLnBrk="0" hangingPunct="1">
+    <a:lvl2pPr marL="457200" algn="l" defTabSz="457200" rtl="0" eaLnBrk="1" latinLnBrk="0" hangingPunct="1">
       <a:defRPr sz="1800" kern="1200">
         <a:solidFill>
           <a:schemeClr val="tx1"/>
@@ -41,7 +41,7 @@
         <a:cs typeface="+mn-cs"/>
       </a:defRPr>
     </a:lvl2pPr>
-    <a:lvl3pPr marL="914400" algn="l" defTabSz="914400" rtl="0" eaLnBrk="1" latinLnBrk="0" hangingPunct="1">
+    <a:lvl3pPr marL="914400" algn="l" defTabSz="457200" rtl="0" eaLnBrk="1" latinLnBrk="0" hangingPunct="1">
       <a:defRPr sz="1800" kern="1200">
         <a:solidFill>
           <a:schemeClr val="tx1"/>
@@ -51,7 +51,7 @@
         <a:cs typeface="+mn-cs"/>
       </a:defRPr>
     </a:lvl3pPr>
-    <a:lvl4pPr marL="1371600" algn="l" defTabSz="914400" rtl="0" eaLnBrk="1" latinLnBrk="0" hangingPunct="1">
+    <a:lvl4pPr marL="1371600" algn="l" defTabSz="457200" rtl="0" eaLnBrk="1" latinLnBrk="0" hangingPunct="1">
       <a:defRPr sz="1800" kern="1200">
         <a:solidFill>
           <a:schemeClr val="tx1"/>
@@ -61,7 +61,7 @@
         <a:cs typeface="+mn-cs"/>
       </a:defRPr>
     </a:lvl4pPr>
-    <a:lvl5pPr marL="1828800" algn="l" defTabSz="914400" rtl="0" eaLnBrk="1" latinLnBrk="0" hangingPunct="1">
+    <a:lvl5pPr marL="1828800" algn="l" defTabSz="457200" rtl="0" eaLnBrk="1" latinLnBrk="0" hangingPunct="1">
       <a:defRPr sz="1800" kern="1200">
         <a:solidFill>
           <a:schemeClr val="tx1"/>
@@ -71,7 +71,7 @@
         <a:cs typeface="+mn-cs"/>
       </a:defRPr>
     </a:lvl5pPr>
-    <a:lvl6pPr marL="2286000" algn="l" defTabSz="914400" rtl="0" eaLnBrk="1" latinLnBrk="0" hangingPunct="1">
+    <a:lvl6pPr marL="2286000" algn="l" defTabSz="457200" rtl="0" eaLnBrk="1" latinLnBrk="0" hangingPunct="1">
       <a:defRPr sz="1800" kern="1200">
         <a:solidFill>
           <a:schemeClr val="tx1"/>
@@ -81,7 +81,7 @@
         <a:cs typeface="+mn-cs"/>
       </a:defRPr>
     </a:lvl6pPr>
-    <a:lvl7pPr marL="2743200" algn="l" defTabSz="914400" rtl="0" eaLnBrk="1" latinLnBrk="0" hangingPunct="1">
+    <a:lvl7pPr marL="2743200" algn="l" defTabSz="457200" rtl="0" eaLnBrk="1" latinLnBrk="0" hangingPunct="1">
       <a:defRPr sz="1800" kern="1200">
         <a:solidFill>
           <a:schemeClr val="tx1"/>
@@ -91,7 +91,7 @@
         <a:cs typeface="+mn-cs"/>
       </a:defRPr>
     </a:lvl7pPr>
-    <a:lvl8pPr marL="3200400" algn="l" defTabSz="914400" rtl="0" eaLnBrk="1" latinLnBrk="0" hangingPunct="1">
+    <a:lvl8pPr marL="3200400" algn="l" defTabSz="457200" rtl="0" eaLnBrk="1" latinLnBrk="0" hangingPunct="1">
       <a:defRPr sz="1800" kern="1200">
         <a:solidFill>
           <a:schemeClr val="tx1"/>
@@ -101,7 +101,7 @@
         <a:cs typeface="+mn-cs"/>
       </a:defRPr>
     </a:lvl8pPr>
-    <a:lvl9pPr marL="3657600" algn="l" defTabSz="914400" rtl="0" eaLnBrk="1" latinLnBrk="0" hangingPunct="1">
+    <a:lvl9pPr marL="3657600" algn="l" defTabSz="457200" rtl="0" eaLnBrk="1" latinLnBrk="0" hangingPunct="1">
       <a:defRPr sz="1800" kern="1200">
         <a:solidFill>
           <a:schemeClr val="tx1"/>
@@ -112,6 +112,11 @@
       </a:defRPr>
     </a:lvl9pPr>
   </p:defaultTextStyle>
+  <p:extLst>
+    <p:ext uri="{EFAFB233-063F-42B5-8137-9DF3F51BA10A}">
+      <p15:sldGuideLst xmlns:p15="http://schemas.microsoft.com/office/powerpoint/2012/main"/>
+    </p:ext>
+  </p:extLst>
 </p:presentation>
 </file>
 
@@ -197,7 +202,7 @@
           <a:p>
             <a:fld id="{7EE2B3A1-8D51-4B38-B9C0-A9709D9C7B38}" type="datetimeFigureOut">
               <a:rPr lang="fr-FR" smtClean="0"/>
-              <a:t>07/04/2026</a:t>
+              <a:t>08/04/2026</a:t>
             </a:fld>
             <a:endParaRPr lang="fr-FR"/>
           </a:p>
@@ -215,8 +220,8 @@
         </p:nvSpPr>
         <p:spPr>
           <a:xfrm>
-            <a:off x="685800" y="1143000"/>
-            <a:ext cx="5486400" cy="3086100"/>
+            <a:off x="1371600" y="1143000"/>
+            <a:ext cx="4114800" cy="3086100"/>
           </a:xfrm>
           <a:prstGeom prst="rect">
             <a:avLst/>
@@ -491,7 +496,12 @@
             <p:ph type="sldImg"/>
           </p:nvPr>
         </p:nvSpPr>
-        <p:spPr/>
+        <p:spPr>
+          <a:xfrm>
+            <a:off x="1371600" y="1143000"/>
+            <a:ext cx="4114800" cy="3086100"/>
+          </a:xfrm>
+        </p:spPr>
       </p:sp>
       <p:sp>
         <p:nvSpPr>
@@ -590,13 +600,7 @@
       </p:grpSpPr>
       <p:sp>
         <p:nvSpPr>
-          <p:cNvPr id="2" name="Titre 1">
-            <a:extLst>
-              <a:ext uri="{FF2B5EF4-FFF2-40B4-BE49-F238E27FC236}">
-                <a16:creationId xmlns:a16="http://schemas.microsoft.com/office/drawing/2014/main" id="{4F24448C-20EE-CCAF-745C-17BEC48D43C8}"/>
-              </a:ext>
-            </a:extLst>
-          </p:cNvPr>
+          <p:cNvPr id="2" name="Title 1"/>
           <p:cNvSpPr>
             <a:spLocks noGrp="1"/>
           </p:cNvSpPr>
@@ -606,8 +610,8 @@
         </p:nvSpPr>
         <p:spPr>
           <a:xfrm>
-            <a:off x="1524000" y="1122363"/>
-            <a:ext cx="9144000" cy="2387600"/>
+            <a:off x="685800" y="1122363"/>
+            <a:ext cx="7772400" cy="2387600"/>
           </a:xfrm>
         </p:spPr>
         <p:txBody>
@@ -622,18 +626,13 @@
               <a:rPr lang="fr-FR"/>
               <a:t>Modifiez le style du titre</a:t>
             </a:r>
-          </a:p>
-        </p:txBody>
-      </p:sp>
-      <p:sp>
-        <p:nvSpPr>
-          <p:cNvPr id="3" name="Sous-titre 2">
-            <a:extLst>
-              <a:ext uri="{FF2B5EF4-FFF2-40B4-BE49-F238E27FC236}">
-                <a16:creationId xmlns:a16="http://schemas.microsoft.com/office/drawing/2014/main" id="{9C1F8C79-8C6B-7FB6-CC48-E3D54545B221}"/>
-              </a:ext>
-            </a:extLst>
-          </p:cNvPr>
+            <a:endParaRPr lang="en-US" dirty="0"/>
+          </a:p>
+        </p:txBody>
+      </p:sp>
+      <p:sp>
+        <p:nvSpPr>
+          <p:cNvPr id="3" name="Subtitle 2"/>
           <p:cNvSpPr>
             <a:spLocks noGrp="1"/>
           </p:cNvSpPr>
@@ -643,8 +642,8 @@
         </p:nvSpPr>
         <p:spPr>
           <a:xfrm>
-            <a:off x="1524000" y="3602038"/>
-            <a:ext cx="9144000" cy="1655762"/>
+            <a:off x="1143000" y="3602038"/>
+            <a:ext cx="6858000" cy="1655762"/>
           </a:xfrm>
         </p:spPr>
         <p:txBody>
@@ -692,18 +691,13 @@
               <a:rPr lang="fr-FR"/>
               <a:t>Modifiez le style des sous-titres du masque</a:t>
             </a:r>
-          </a:p>
-        </p:txBody>
-      </p:sp>
-      <p:sp>
-        <p:nvSpPr>
-          <p:cNvPr id="4" name="Espace réservé de la date 3">
-            <a:extLst>
-              <a:ext uri="{FF2B5EF4-FFF2-40B4-BE49-F238E27FC236}">
-                <a16:creationId xmlns:a16="http://schemas.microsoft.com/office/drawing/2014/main" id="{5169C1A9-D704-6E98-8401-F54288EFB3B2}"/>
-              </a:ext>
-            </a:extLst>
-          </p:cNvPr>
+            <a:endParaRPr lang="en-US" dirty="0"/>
+          </a:p>
+        </p:txBody>
+      </p:sp>
+      <p:sp>
+        <p:nvSpPr>
+          <p:cNvPr id="4" name="Date Placeholder 3"/>
           <p:cNvSpPr>
             <a:spLocks noGrp="1"/>
           </p:cNvSpPr>
@@ -718,7 +712,7 @@
           <a:p>
             <a:fld id="{5511EBAF-3E89-4224-B894-EF8FC8703D29}" type="datetimeFigureOut">
               <a:rPr lang="fr-FR" smtClean="0"/>
-              <a:t>07/04/2026</a:t>
+              <a:t>08/04/2026</a:t>
             </a:fld>
             <a:endParaRPr lang="fr-FR"/>
           </a:p>
@@ -726,13 +720,7 @@
       </p:sp>
       <p:sp>
         <p:nvSpPr>
-          <p:cNvPr id="5" name="Espace réservé du pied de page 4">
-            <a:extLst>
-              <a:ext uri="{FF2B5EF4-FFF2-40B4-BE49-F238E27FC236}">
-                <a16:creationId xmlns:a16="http://schemas.microsoft.com/office/drawing/2014/main" id="{E1481660-016C-339C-65AA-FDD2DE65761C}"/>
-              </a:ext>
-            </a:extLst>
-          </p:cNvPr>
+          <p:cNvPr id="5" name="Footer Placeholder 4"/>
           <p:cNvSpPr>
             <a:spLocks noGrp="1"/>
           </p:cNvSpPr>
@@ -751,13 +739,7 @@
       </p:sp>
       <p:sp>
         <p:nvSpPr>
-          <p:cNvPr id="6" name="Espace réservé du numéro de diapositive 5">
-            <a:extLst>
-              <a:ext uri="{FF2B5EF4-FFF2-40B4-BE49-F238E27FC236}">
-                <a16:creationId xmlns:a16="http://schemas.microsoft.com/office/drawing/2014/main" id="{3B1459C9-1479-39DA-8372-299D1DC34456}"/>
-              </a:ext>
-            </a:extLst>
-          </p:cNvPr>
+          <p:cNvPr id="6" name="Slide Number Placeholder 5"/>
           <p:cNvSpPr>
             <a:spLocks noGrp="1"/>
           </p:cNvSpPr>
@@ -781,7 +763,7 @@
     </p:spTree>
     <p:extLst>
       <p:ext uri="{BB962C8B-B14F-4D97-AF65-F5344CB8AC3E}">
-        <p14:creationId xmlns:p14="http://schemas.microsoft.com/office/powerpoint/2010/main" val="914679974"/>
+        <p14:creationId xmlns:p14="http://schemas.microsoft.com/office/powerpoint/2010/main" val="3702709298"/>
       </p:ext>
     </p:extLst>
   </p:cSld>
@@ -810,13 +792,7 @@
       </p:grpSpPr>
       <p:sp>
         <p:nvSpPr>
-          <p:cNvPr id="2" name="Titre 1">
-            <a:extLst>
-              <a:ext uri="{FF2B5EF4-FFF2-40B4-BE49-F238E27FC236}">
-                <a16:creationId xmlns:a16="http://schemas.microsoft.com/office/drawing/2014/main" id="{B6581318-CBC7-6EA4-11B1-B3F47905D0B9}"/>
-              </a:ext>
-            </a:extLst>
-          </p:cNvPr>
+          <p:cNvPr id="2" name="Title 1"/>
           <p:cNvSpPr>
             <a:spLocks noGrp="1"/>
           </p:cNvSpPr>
@@ -833,18 +809,13 @@
               <a:rPr lang="fr-FR"/>
               <a:t>Modifiez le style du titre</a:t>
             </a:r>
-          </a:p>
-        </p:txBody>
-      </p:sp>
-      <p:sp>
-        <p:nvSpPr>
-          <p:cNvPr id="3" name="Espace réservé du texte vertical 2">
-            <a:extLst>
-              <a:ext uri="{FF2B5EF4-FFF2-40B4-BE49-F238E27FC236}">
-                <a16:creationId xmlns:a16="http://schemas.microsoft.com/office/drawing/2014/main" id="{4B4CD4B4-8DE4-05A5-4F5B-3DBB290BCFD6}"/>
-              </a:ext>
-            </a:extLst>
-          </p:cNvPr>
+            <a:endParaRPr lang="en-US" dirty="0"/>
+          </a:p>
+        </p:txBody>
+      </p:sp>
+      <p:sp>
+        <p:nvSpPr>
+          <p:cNvPr id="3" name="Vertical Text Placeholder 2"/>
           <p:cNvSpPr>
             <a:spLocks noGrp="1"/>
           </p:cNvSpPr>
@@ -890,18 +861,13 @@
               <a:rPr lang="fr-FR"/>
               <a:t>Cinquième niveau</a:t>
             </a:r>
-          </a:p>
-        </p:txBody>
-      </p:sp>
-      <p:sp>
-        <p:nvSpPr>
-          <p:cNvPr id="4" name="Espace réservé de la date 3">
-            <a:extLst>
-              <a:ext uri="{FF2B5EF4-FFF2-40B4-BE49-F238E27FC236}">
-                <a16:creationId xmlns:a16="http://schemas.microsoft.com/office/drawing/2014/main" id="{8A50856D-7824-4E6E-46DD-088613DCA454}"/>
-              </a:ext>
-            </a:extLst>
-          </p:cNvPr>
+            <a:endParaRPr lang="en-US" dirty="0"/>
+          </a:p>
+        </p:txBody>
+      </p:sp>
+      <p:sp>
+        <p:nvSpPr>
+          <p:cNvPr id="4" name="Date Placeholder 3"/>
           <p:cNvSpPr>
             <a:spLocks noGrp="1"/>
           </p:cNvSpPr>
@@ -916,7 +882,7 @@
           <a:p>
             <a:fld id="{5511EBAF-3E89-4224-B894-EF8FC8703D29}" type="datetimeFigureOut">
               <a:rPr lang="fr-FR" smtClean="0"/>
-              <a:t>07/04/2026</a:t>
+              <a:t>08/04/2026</a:t>
             </a:fld>
             <a:endParaRPr lang="fr-FR"/>
           </a:p>
@@ -924,13 +890,7 @@
       </p:sp>
       <p:sp>
         <p:nvSpPr>
-          <p:cNvPr id="5" name="Espace réservé du pied de page 4">
-            <a:extLst>
-              <a:ext uri="{FF2B5EF4-FFF2-40B4-BE49-F238E27FC236}">
-                <a16:creationId xmlns:a16="http://schemas.microsoft.com/office/drawing/2014/main" id="{1C7C3155-E94C-EEA3-41AE-EC172B2EB3A9}"/>
-              </a:ext>
-            </a:extLst>
-          </p:cNvPr>
+          <p:cNvPr id="5" name="Footer Placeholder 4"/>
           <p:cNvSpPr>
             <a:spLocks noGrp="1"/>
           </p:cNvSpPr>
@@ -949,13 +909,7 @@
       </p:sp>
       <p:sp>
         <p:nvSpPr>
-          <p:cNvPr id="6" name="Espace réservé du numéro de diapositive 5">
-            <a:extLst>
-              <a:ext uri="{FF2B5EF4-FFF2-40B4-BE49-F238E27FC236}">
-                <a16:creationId xmlns:a16="http://schemas.microsoft.com/office/drawing/2014/main" id="{981AC440-2FD1-F173-4188-895DBAB8385D}"/>
-              </a:ext>
-            </a:extLst>
-          </p:cNvPr>
+          <p:cNvPr id="6" name="Slide Number Placeholder 5"/>
           <p:cNvSpPr>
             <a:spLocks noGrp="1"/>
           </p:cNvSpPr>
@@ -979,7 +933,7 @@
     </p:spTree>
     <p:extLst>
       <p:ext uri="{BB962C8B-B14F-4D97-AF65-F5344CB8AC3E}">
-        <p14:creationId xmlns:p14="http://schemas.microsoft.com/office/powerpoint/2010/main" val="4130096240"/>
+        <p14:creationId xmlns:p14="http://schemas.microsoft.com/office/powerpoint/2010/main" val="1246888402"/>
       </p:ext>
     </p:extLst>
   </p:cSld>
@@ -1008,13 +962,7 @@
       </p:grpSpPr>
       <p:sp>
         <p:nvSpPr>
-          <p:cNvPr id="2" name="Titre vertical 1">
-            <a:extLst>
-              <a:ext uri="{FF2B5EF4-FFF2-40B4-BE49-F238E27FC236}">
-                <a16:creationId xmlns:a16="http://schemas.microsoft.com/office/drawing/2014/main" id="{CF8943A7-6FA7-AD41-E683-3543DCA60964}"/>
-              </a:ext>
-            </a:extLst>
-          </p:cNvPr>
+          <p:cNvPr id="2" name="Vertical Title 1"/>
           <p:cNvSpPr>
             <a:spLocks noGrp="1"/>
           </p:cNvSpPr>
@@ -1024,8 +972,8 @@
         </p:nvSpPr>
         <p:spPr>
           <a:xfrm>
-            <a:off x="8724900" y="365125"/>
-            <a:ext cx="2628900" cy="5811838"/>
+            <a:off x="6543675" y="365125"/>
+            <a:ext cx="1971675" cy="5811838"/>
           </a:xfrm>
         </p:spPr>
         <p:txBody>
@@ -1036,18 +984,13 @@
               <a:rPr lang="fr-FR"/>
               <a:t>Modifiez le style du titre</a:t>
             </a:r>
-          </a:p>
-        </p:txBody>
-      </p:sp>
-      <p:sp>
-        <p:nvSpPr>
-          <p:cNvPr id="3" name="Espace réservé du texte vertical 2">
-            <a:extLst>
-              <a:ext uri="{FF2B5EF4-FFF2-40B4-BE49-F238E27FC236}">
-                <a16:creationId xmlns:a16="http://schemas.microsoft.com/office/drawing/2014/main" id="{A2181DFF-6ABB-882B-5A05-E90DC3C3E0EA}"/>
-              </a:ext>
-            </a:extLst>
-          </p:cNvPr>
+            <a:endParaRPr lang="en-US" dirty="0"/>
+          </a:p>
+        </p:txBody>
+      </p:sp>
+      <p:sp>
+        <p:nvSpPr>
+          <p:cNvPr id="3" name="Vertical Text Placeholder 2"/>
           <p:cNvSpPr>
             <a:spLocks noGrp="1"/>
           </p:cNvSpPr>
@@ -1057,8 +1000,8 @@
         </p:nvSpPr>
         <p:spPr>
           <a:xfrm>
-            <a:off x="838200" y="365125"/>
-            <a:ext cx="7734300" cy="5811838"/>
+            <a:off x="628650" y="365125"/>
+            <a:ext cx="5800725" cy="5811838"/>
           </a:xfrm>
         </p:spPr>
         <p:txBody>
@@ -1098,18 +1041,13 @@
               <a:rPr lang="fr-FR"/>
               <a:t>Cinquième niveau</a:t>
             </a:r>
-          </a:p>
-        </p:txBody>
-      </p:sp>
-      <p:sp>
-        <p:nvSpPr>
-          <p:cNvPr id="4" name="Espace réservé de la date 3">
-            <a:extLst>
-              <a:ext uri="{FF2B5EF4-FFF2-40B4-BE49-F238E27FC236}">
-                <a16:creationId xmlns:a16="http://schemas.microsoft.com/office/drawing/2014/main" id="{72452C34-071D-BF0E-323E-EC3D1046B2DE}"/>
-              </a:ext>
-            </a:extLst>
-          </p:cNvPr>
+            <a:endParaRPr lang="en-US" dirty="0"/>
+          </a:p>
+        </p:txBody>
+      </p:sp>
+      <p:sp>
+        <p:nvSpPr>
+          <p:cNvPr id="4" name="Date Placeholder 3"/>
           <p:cNvSpPr>
             <a:spLocks noGrp="1"/>
           </p:cNvSpPr>
@@ -1124,7 +1062,7 @@
           <a:p>
             <a:fld id="{5511EBAF-3E89-4224-B894-EF8FC8703D29}" type="datetimeFigureOut">
               <a:rPr lang="fr-FR" smtClean="0"/>
-              <a:t>07/04/2026</a:t>
+              <a:t>08/04/2026</a:t>
             </a:fld>
             <a:endParaRPr lang="fr-FR"/>
           </a:p>
@@ -1132,13 +1070,7 @@
       </p:sp>
       <p:sp>
         <p:nvSpPr>
-          <p:cNvPr id="5" name="Espace réservé du pied de page 4">
-            <a:extLst>
-              <a:ext uri="{FF2B5EF4-FFF2-40B4-BE49-F238E27FC236}">
-                <a16:creationId xmlns:a16="http://schemas.microsoft.com/office/drawing/2014/main" id="{19572C6D-77F5-CE9E-BAC8-8C040849AC65}"/>
-              </a:ext>
-            </a:extLst>
-          </p:cNvPr>
+          <p:cNvPr id="5" name="Footer Placeholder 4"/>
           <p:cNvSpPr>
             <a:spLocks noGrp="1"/>
           </p:cNvSpPr>
@@ -1157,13 +1089,7 @@
       </p:sp>
       <p:sp>
         <p:nvSpPr>
-          <p:cNvPr id="6" name="Espace réservé du numéro de diapositive 5">
-            <a:extLst>
-              <a:ext uri="{FF2B5EF4-FFF2-40B4-BE49-F238E27FC236}">
-                <a16:creationId xmlns:a16="http://schemas.microsoft.com/office/drawing/2014/main" id="{6F013A5C-39AA-880E-36FE-1F53B7163F8F}"/>
-              </a:ext>
-            </a:extLst>
-          </p:cNvPr>
+          <p:cNvPr id="6" name="Slide Number Placeholder 5"/>
           <p:cNvSpPr>
             <a:spLocks noGrp="1"/>
           </p:cNvSpPr>
@@ -1187,7 +1113,7 @@
     </p:spTree>
     <p:extLst>
       <p:ext uri="{BB962C8B-B14F-4D97-AF65-F5344CB8AC3E}">
-        <p14:creationId xmlns:p14="http://schemas.microsoft.com/office/powerpoint/2010/main" val="496362677"/>
+        <p14:creationId xmlns:p14="http://schemas.microsoft.com/office/powerpoint/2010/main" val="1766316737"/>
       </p:ext>
     </p:extLst>
   </p:cSld>
@@ -1216,13 +1142,7 @@
       </p:grpSpPr>
       <p:sp>
         <p:nvSpPr>
-          <p:cNvPr id="2" name="Titre 1">
-            <a:extLst>
-              <a:ext uri="{FF2B5EF4-FFF2-40B4-BE49-F238E27FC236}">
-                <a16:creationId xmlns:a16="http://schemas.microsoft.com/office/drawing/2014/main" id="{73CB0E05-AF3D-44FF-B300-770D4D919869}"/>
-              </a:ext>
-            </a:extLst>
-          </p:cNvPr>
+          <p:cNvPr id="2" name="Title 1"/>
           <p:cNvSpPr>
             <a:spLocks noGrp="1"/>
           </p:cNvSpPr>
@@ -1239,18 +1159,13 @@
               <a:rPr lang="fr-FR"/>
               <a:t>Modifiez le style du titre</a:t>
             </a:r>
-          </a:p>
-        </p:txBody>
-      </p:sp>
-      <p:sp>
-        <p:nvSpPr>
-          <p:cNvPr id="3" name="Espace réservé du contenu 2">
-            <a:extLst>
-              <a:ext uri="{FF2B5EF4-FFF2-40B4-BE49-F238E27FC236}">
-                <a16:creationId xmlns:a16="http://schemas.microsoft.com/office/drawing/2014/main" id="{1CDE1A56-F325-CD26-1158-CFA435C38021}"/>
-              </a:ext>
-            </a:extLst>
-          </p:cNvPr>
+            <a:endParaRPr lang="en-US" dirty="0"/>
+          </a:p>
+        </p:txBody>
+      </p:sp>
+      <p:sp>
+        <p:nvSpPr>
+          <p:cNvPr id="3" name="Content Placeholder 2"/>
           <p:cNvSpPr>
             <a:spLocks noGrp="1"/>
           </p:cNvSpPr>
@@ -1296,18 +1211,13 @@
               <a:rPr lang="fr-FR"/>
               <a:t>Cinquième niveau</a:t>
             </a:r>
-          </a:p>
-        </p:txBody>
-      </p:sp>
-      <p:sp>
-        <p:nvSpPr>
-          <p:cNvPr id="4" name="Espace réservé de la date 3">
-            <a:extLst>
-              <a:ext uri="{FF2B5EF4-FFF2-40B4-BE49-F238E27FC236}">
-                <a16:creationId xmlns:a16="http://schemas.microsoft.com/office/drawing/2014/main" id="{C4144F94-8416-749F-B8D8-192FF02A7311}"/>
-              </a:ext>
-            </a:extLst>
-          </p:cNvPr>
+            <a:endParaRPr lang="en-US" dirty="0"/>
+          </a:p>
+        </p:txBody>
+      </p:sp>
+      <p:sp>
+        <p:nvSpPr>
+          <p:cNvPr id="4" name="Date Placeholder 3"/>
           <p:cNvSpPr>
             <a:spLocks noGrp="1"/>
           </p:cNvSpPr>
@@ -1322,7 +1232,7 @@
           <a:p>
             <a:fld id="{5511EBAF-3E89-4224-B894-EF8FC8703D29}" type="datetimeFigureOut">
               <a:rPr lang="fr-FR" smtClean="0"/>
-              <a:t>07/04/2026</a:t>
+              <a:t>08/04/2026</a:t>
             </a:fld>
             <a:endParaRPr lang="fr-FR"/>
           </a:p>
@@ -1330,13 +1240,7 @@
       </p:sp>
       <p:sp>
         <p:nvSpPr>
-          <p:cNvPr id="5" name="Espace réservé du pied de page 4">
-            <a:extLst>
-              <a:ext uri="{FF2B5EF4-FFF2-40B4-BE49-F238E27FC236}">
-                <a16:creationId xmlns:a16="http://schemas.microsoft.com/office/drawing/2014/main" id="{ACDCDBA4-A5C3-9A41-B96D-4EA023C537D4}"/>
-              </a:ext>
-            </a:extLst>
-          </p:cNvPr>
+          <p:cNvPr id="5" name="Footer Placeholder 4"/>
           <p:cNvSpPr>
             <a:spLocks noGrp="1"/>
           </p:cNvSpPr>
@@ -1355,13 +1259,7 @@
       </p:sp>
       <p:sp>
         <p:nvSpPr>
-          <p:cNvPr id="6" name="Espace réservé du numéro de diapositive 5">
-            <a:extLst>
-              <a:ext uri="{FF2B5EF4-FFF2-40B4-BE49-F238E27FC236}">
-                <a16:creationId xmlns:a16="http://schemas.microsoft.com/office/drawing/2014/main" id="{F8CC0B34-EDD4-4276-F8C4-B0463E732398}"/>
-              </a:ext>
-            </a:extLst>
-          </p:cNvPr>
+          <p:cNvPr id="6" name="Slide Number Placeholder 5"/>
           <p:cNvSpPr>
             <a:spLocks noGrp="1"/>
           </p:cNvSpPr>
@@ -1385,7 +1283,7 @@
     </p:spTree>
     <p:extLst>
       <p:ext uri="{BB962C8B-B14F-4D97-AF65-F5344CB8AC3E}">
-        <p14:creationId xmlns:p14="http://schemas.microsoft.com/office/powerpoint/2010/main" val="1548547330"/>
+        <p14:creationId xmlns:p14="http://schemas.microsoft.com/office/powerpoint/2010/main" val="1687213314"/>
       </p:ext>
     </p:extLst>
   </p:cSld>
@@ -1414,13 +1312,7 @@
       </p:grpSpPr>
       <p:sp>
         <p:nvSpPr>
-          <p:cNvPr id="2" name="Titre 1">
-            <a:extLst>
-              <a:ext uri="{FF2B5EF4-FFF2-40B4-BE49-F238E27FC236}">
-                <a16:creationId xmlns:a16="http://schemas.microsoft.com/office/drawing/2014/main" id="{D882C3BB-604E-9BEA-06C0-4FBE52EB9349}"/>
-              </a:ext>
-            </a:extLst>
-          </p:cNvPr>
+          <p:cNvPr id="2" name="Title 1"/>
           <p:cNvSpPr>
             <a:spLocks noGrp="1"/>
           </p:cNvSpPr>
@@ -1430,8 +1322,8 @@
         </p:nvSpPr>
         <p:spPr>
           <a:xfrm>
-            <a:off x="831850" y="1709738"/>
-            <a:ext cx="10515600" cy="2852737"/>
+            <a:off x="623888" y="1709739"/>
+            <a:ext cx="7886700" cy="2852737"/>
           </a:xfrm>
         </p:spPr>
         <p:txBody>
@@ -1446,18 +1338,13 @@
               <a:rPr lang="fr-FR"/>
               <a:t>Modifiez le style du titre</a:t>
             </a:r>
-          </a:p>
-        </p:txBody>
-      </p:sp>
-      <p:sp>
-        <p:nvSpPr>
-          <p:cNvPr id="3" name="Espace réservé du texte 2">
-            <a:extLst>
-              <a:ext uri="{FF2B5EF4-FFF2-40B4-BE49-F238E27FC236}">
-                <a16:creationId xmlns:a16="http://schemas.microsoft.com/office/drawing/2014/main" id="{34F7546A-05F4-B3FC-A236-D893814BD424}"/>
-              </a:ext>
-            </a:extLst>
-          </p:cNvPr>
+            <a:endParaRPr lang="en-US" dirty="0"/>
+          </a:p>
+        </p:txBody>
+      </p:sp>
+      <p:sp>
+        <p:nvSpPr>
+          <p:cNvPr id="3" name="Text Placeholder 2"/>
           <p:cNvSpPr>
             <a:spLocks noGrp="1"/>
           </p:cNvSpPr>
@@ -1467,8 +1354,8 @@
         </p:nvSpPr>
         <p:spPr>
           <a:xfrm>
-            <a:off x="831850" y="4589463"/>
-            <a:ext cx="10515600" cy="1500187"/>
+            <a:off x="623888" y="4589464"/>
+            <a:ext cx="7886700" cy="1500187"/>
           </a:xfrm>
         </p:spPr>
         <p:txBody>
@@ -1576,13 +1463,7 @@
       </p:sp>
       <p:sp>
         <p:nvSpPr>
-          <p:cNvPr id="4" name="Espace réservé de la date 3">
-            <a:extLst>
-              <a:ext uri="{FF2B5EF4-FFF2-40B4-BE49-F238E27FC236}">
-                <a16:creationId xmlns:a16="http://schemas.microsoft.com/office/drawing/2014/main" id="{46B9CC7B-145A-20F5-88C5-1304E8DBCE3E}"/>
-              </a:ext>
-            </a:extLst>
-          </p:cNvPr>
+          <p:cNvPr id="4" name="Date Placeholder 3"/>
           <p:cNvSpPr>
             <a:spLocks noGrp="1"/>
           </p:cNvSpPr>
@@ -1597,7 +1478,7 @@
           <a:p>
             <a:fld id="{5511EBAF-3E89-4224-B894-EF8FC8703D29}" type="datetimeFigureOut">
               <a:rPr lang="fr-FR" smtClean="0"/>
-              <a:t>07/04/2026</a:t>
+              <a:t>08/04/2026</a:t>
             </a:fld>
             <a:endParaRPr lang="fr-FR"/>
           </a:p>
@@ -1605,13 +1486,7 @@
       </p:sp>
       <p:sp>
         <p:nvSpPr>
-          <p:cNvPr id="5" name="Espace réservé du pied de page 4">
-            <a:extLst>
-              <a:ext uri="{FF2B5EF4-FFF2-40B4-BE49-F238E27FC236}">
-                <a16:creationId xmlns:a16="http://schemas.microsoft.com/office/drawing/2014/main" id="{69EBD45D-40B8-47D6-3D20-CDB015A305D3}"/>
-              </a:ext>
-            </a:extLst>
-          </p:cNvPr>
+          <p:cNvPr id="5" name="Footer Placeholder 4"/>
           <p:cNvSpPr>
             <a:spLocks noGrp="1"/>
           </p:cNvSpPr>
@@ -1630,13 +1505,7 @@
       </p:sp>
       <p:sp>
         <p:nvSpPr>
-          <p:cNvPr id="6" name="Espace réservé du numéro de diapositive 5">
-            <a:extLst>
-              <a:ext uri="{FF2B5EF4-FFF2-40B4-BE49-F238E27FC236}">
-                <a16:creationId xmlns:a16="http://schemas.microsoft.com/office/drawing/2014/main" id="{8184EF95-7DE7-9A5E-AFDB-A6F184B272B0}"/>
-              </a:ext>
-            </a:extLst>
-          </p:cNvPr>
+          <p:cNvPr id="6" name="Slide Number Placeholder 5"/>
           <p:cNvSpPr>
             <a:spLocks noGrp="1"/>
           </p:cNvSpPr>
@@ -1660,7 +1529,7 @@
     </p:spTree>
     <p:extLst>
       <p:ext uri="{BB962C8B-B14F-4D97-AF65-F5344CB8AC3E}">
-        <p14:creationId xmlns:p14="http://schemas.microsoft.com/office/powerpoint/2010/main" val="4147954992"/>
+        <p14:creationId xmlns:p14="http://schemas.microsoft.com/office/powerpoint/2010/main" val="2590569328"/>
       </p:ext>
     </p:extLst>
   </p:cSld>
@@ -1689,13 +1558,7 @@
       </p:grpSpPr>
       <p:sp>
         <p:nvSpPr>
-          <p:cNvPr id="2" name="Titre 1">
-            <a:extLst>
-              <a:ext uri="{FF2B5EF4-FFF2-40B4-BE49-F238E27FC236}">
-                <a16:creationId xmlns:a16="http://schemas.microsoft.com/office/drawing/2014/main" id="{E30D06C6-06AF-EF90-1FEA-5094D93B1807}"/>
-              </a:ext>
-            </a:extLst>
-          </p:cNvPr>
+          <p:cNvPr id="2" name="Title 1"/>
           <p:cNvSpPr>
             <a:spLocks noGrp="1"/>
           </p:cNvSpPr>
@@ -1712,18 +1575,13 @@
               <a:rPr lang="fr-FR"/>
               <a:t>Modifiez le style du titre</a:t>
             </a:r>
-          </a:p>
-        </p:txBody>
-      </p:sp>
-      <p:sp>
-        <p:nvSpPr>
-          <p:cNvPr id="3" name="Espace réservé du contenu 2">
-            <a:extLst>
-              <a:ext uri="{FF2B5EF4-FFF2-40B4-BE49-F238E27FC236}">
-                <a16:creationId xmlns:a16="http://schemas.microsoft.com/office/drawing/2014/main" id="{F240A057-2B03-D05F-820D-034B34CA7F20}"/>
-              </a:ext>
-            </a:extLst>
-          </p:cNvPr>
+            <a:endParaRPr lang="en-US" dirty="0"/>
+          </a:p>
+        </p:txBody>
+      </p:sp>
+      <p:sp>
+        <p:nvSpPr>
+          <p:cNvPr id="3" name="Content Placeholder 2"/>
           <p:cNvSpPr>
             <a:spLocks noGrp="1"/>
           </p:cNvSpPr>
@@ -1733,8 +1591,8 @@
         </p:nvSpPr>
         <p:spPr>
           <a:xfrm>
-            <a:off x="838200" y="1825625"/>
-            <a:ext cx="5181600" cy="4351338"/>
+            <a:off x="628650" y="1825625"/>
+            <a:ext cx="3886200" cy="4351338"/>
           </a:xfrm>
         </p:spPr>
         <p:txBody>
@@ -1774,18 +1632,13 @@
               <a:rPr lang="fr-FR"/>
               <a:t>Cinquième niveau</a:t>
             </a:r>
-          </a:p>
-        </p:txBody>
-      </p:sp>
-      <p:sp>
-        <p:nvSpPr>
-          <p:cNvPr id="4" name="Espace réservé du contenu 3">
-            <a:extLst>
-              <a:ext uri="{FF2B5EF4-FFF2-40B4-BE49-F238E27FC236}">
-                <a16:creationId xmlns:a16="http://schemas.microsoft.com/office/drawing/2014/main" id="{71090595-4E20-8B69-2E6F-ADB1046B6023}"/>
-              </a:ext>
-            </a:extLst>
-          </p:cNvPr>
+            <a:endParaRPr lang="en-US" dirty="0"/>
+          </a:p>
+        </p:txBody>
+      </p:sp>
+      <p:sp>
+        <p:nvSpPr>
+          <p:cNvPr id="4" name="Content Placeholder 3"/>
           <p:cNvSpPr>
             <a:spLocks noGrp="1"/>
           </p:cNvSpPr>
@@ -1795,8 +1648,8 @@
         </p:nvSpPr>
         <p:spPr>
           <a:xfrm>
-            <a:off x="6172200" y="1825625"/>
-            <a:ext cx="5181600" cy="4351338"/>
+            <a:off x="4629150" y="1825625"/>
+            <a:ext cx="3886200" cy="4351338"/>
           </a:xfrm>
         </p:spPr>
         <p:txBody>
@@ -1836,18 +1689,13 @@
               <a:rPr lang="fr-FR"/>
               <a:t>Cinquième niveau</a:t>
             </a:r>
-          </a:p>
-        </p:txBody>
-      </p:sp>
-      <p:sp>
-        <p:nvSpPr>
-          <p:cNvPr id="5" name="Espace réservé de la date 4">
-            <a:extLst>
-              <a:ext uri="{FF2B5EF4-FFF2-40B4-BE49-F238E27FC236}">
-                <a16:creationId xmlns:a16="http://schemas.microsoft.com/office/drawing/2014/main" id="{24E2080C-F7BC-D820-61AD-93E2657A989D}"/>
-              </a:ext>
-            </a:extLst>
-          </p:cNvPr>
+            <a:endParaRPr lang="en-US" dirty="0"/>
+          </a:p>
+        </p:txBody>
+      </p:sp>
+      <p:sp>
+        <p:nvSpPr>
+          <p:cNvPr id="5" name="Date Placeholder 4"/>
           <p:cNvSpPr>
             <a:spLocks noGrp="1"/>
           </p:cNvSpPr>
@@ -1862,7 +1710,7 @@
           <a:p>
             <a:fld id="{5511EBAF-3E89-4224-B894-EF8FC8703D29}" type="datetimeFigureOut">
               <a:rPr lang="fr-FR" smtClean="0"/>
-              <a:t>07/04/2026</a:t>
+              <a:t>08/04/2026</a:t>
             </a:fld>
             <a:endParaRPr lang="fr-FR"/>
           </a:p>
@@ -1870,13 +1718,7 @@
       </p:sp>
       <p:sp>
         <p:nvSpPr>
-          <p:cNvPr id="6" name="Espace réservé du pied de page 5">
-            <a:extLst>
-              <a:ext uri="{FF2B5EF4-FFF2-40B4-BE49-F238E27FC236}">
-                <a16:creationId xmlns:a16="http://schemas.microsoft.com/office/drawing/2014/main" id="{7F453E70-50BE-86B2-5F61-991548801A28}"/>
-              </a:ext>
-            </a:extLst>
-          </p:cNvPr>
+          <p:cNvPr id="6" name="Footer Placeholder 5"/>
           <p:cNvSpPr>
             <a:spLocks noGrp="1"/>
           </p:cNvSpPr>
@@ -1895,13 +1737,7 @@
       </p:sp>
       <p:sp>
         <p:nvSpPr>
-          <p:cNvPr id="7" name="Espace réservé du numéro de diapositive 6">
-            <a:extLst>
-              <a:ext uri="{FF2B5EF4-FFF2-40B4-BE49-F238E27FC236}">
-                <a16:creationId xmlns:a16="http://schemas.microsoft.com/office/drawing/2014/main" id="{956C68C3-D143-7688-0656-802CBFF192B4}"/>
-              </a:ext>
-            </a:extLst>
-          </p:cNvPr>
+          <p:cNvPr id="7" name="Slide Number Placeholder 6"/>
           <p:cNvSpPr>
             <a:spLocks noGrp="1"/>
           </p:cNvSpPr>
@@ -1925,7 +1761,7 @@
     </p:spTree>
     <p:extLst>
       <p:ext uri="{BB962C8B-B14F-4D97-AF65-F5344CB8AC3E}">
-        <p14:creationId xmlns:p14="http://schemas.microsoft.com/office/powerpoint/2010/main" val="3832421117"/>
+        <p14:creationId xmlns:p14="http://schemas.microsoft.com/office/powerpoint/2010/main" val="2740246225"/>
       </p:ext>
     </p:extLst>
   </p:cSld>
@@ -1954,13 +1790,7 @@
       </p:grpSpPr>
       <p:sp>
         <p:nvSpPr>
-          <p:cNvPr id="2" name="Titre 1">
-            <a:extLst>
-              <a:ext uri="{FF2B5EF4-FFF2-40B4-BE49-F238E27FC236}">
-                <a16:creationId xmlns:a16="http://schemas.microsoft.com/office/drawing/2014/main" id="{CCCCE03B-2878-7D18-3FE5-7428605710E9}"/>
-              </a:ext>
-            </a:extLst>
-          </p:cNvPr>
+          <p:cNvPr id="2" name="Title 1"/>
           <p:cNvSpPr>
             <a:spLocks noGrp="1"/>
           </p:cNvSpPr>
@@ -1970,8 +1800,8 @@
         </p:nvSpPr>
         <p:spPr>
           <a:xfrm>
-            <a:off x="839788" y="365125"/>
-            <a:ext cx="10515600" cy="1325563"/>
+            <a:off x="629841" y="365126"/>
+            <a:ext cx="7886700" cy="1325563"/>
           </a:xfrm>
         </p:spPr>
         <p:txBody>
@@ -1982,18 +1812,13 @@
               <a:rPr lang="fr-FR"/>
               <a:t>Modifiez le style du titre</a:t>
             </a:r>
-          </a:p>
-        </p:txBody>
-      </p:sp>
-      <p:sp>
-        <p:nvSpPr>
-          <p:cNvPr id="3" name="Espace réservé du texte 2">
-            <a:extLst>
-              <a:ext uri="{FF2B5EF4-FFF2-40B4-BE49-F238E27FC236}">
-                <a16:creationId xmlns:a16="http://schemas.microsoft.com/office/drawing/2014/main" id="{2DAB3330-9F54-0EF1-CC47-5CD7CBF1DA88}"/>
-              </a:ext>
-            </a:extLst>
-          </p:cNvPr>
+            <a:endParaRPr lang="en-US" dirty="0"/>
+          </a:p>
+        </p:txBody>
+      </p:sp>
+      <p:sp>
+        <p:nvSpPr>
+          <p:cNvPr id="3" name="Text Placeholder 2"/>
           <p:cNvSpPr>
             <a:spLocks noGrp="1"/>
           </p:cNvSpPr>
@@ -2003,8 +1828,8 @@
         </p:nvSpPr>
         <p:spPr>
           <a:xfrm>
-            <a:off x="839788" y="1681163"/>
-            <a:ext cx="5157787" cy="823912"/>
+            <a:off x="629842" y="1681163"/>
+            <a:ext cx="3868340" cy="823912"/>
           </a:xfrm>
         </p:spPr>
         <p:txBody>
@@ -2058,13 +1883,7 @@
       </p:sp>
       <p:sp>
         <p:nvSpPr>
-          <p:cNvPr id="4" name="Espace réservé du contenu 3">
-            <a:extLst>
-              <a:ext uri="{FF2B5EF4-FFF2-40B4-BE49-F238E27FC236}">
-                <a16:creationId xmlns:a16="http://schemas.microsoft.com/office/drawing/2014/main" id="{CDC31E13-6198-C9A8-1DB1-31CB9B2C7BE7}"/>
-              </a:ext>
-            </a:extLst>
-          </p:cNvPr>
+          <p:cNvPr id="4" name="Content Placeholder 3"/>
           <p:cNvSpPr>
             <a:spLocks noGrp="1"/>
           </p:cNvSpPr>
@@ -2074,8 +1893,8 @@
         </p:nvSpPr>
         <p:spPr>
           <a:xfrm>
-            <a:off x="839788" y="2505075"/>
-            <a:ext cx="5157787" cy="3684588"/>
+            <a:off x="629842" y="2505075"/>
+            <a:ext cx="3868340" cy="3684588"/>
           </a:xfrm>
         </p:spPr>
         <p:txBody>
@@ -2115,18 +1934,13 @@
               <a:rPr lang="fr-FR"/>
               <a:t>Cinquième niveau</a:t>
             </a:r>
-          </a:p>
-        </p:txBody>
-      </p:sp>
-      <p:sp>
-        <p:nvSpPr>
-          <p:cNvPr id="5" name="Espace réservé du texte 4">
-            <a:extLst>
-              <a:ext uri="{FF2B5EF4-FFF2-40B4-BE49-F238E27FC236}">
-                <a16:creationId xmlns:a16="http://schemas.microsoft.com/office/drawing/2014/main" id="{48E1B290-D147-C623-A9A6-211AAB701FD0}"/>
-              </a:ext>
-            </a:extLst>
-          </p:cNvPr>
+            <a:endParaRPr lang="en-US" dirty="0"/>
+          </a:p>
+        </p:txBody>
+      </p:sp>
+      <p:sp>
+        <p:nvSpPr>
+          <p:cNvPr id="5" name="Text Placeholder 4"/>
           <p:cNvSpPr>
             <a:spLocks noGrp="1"/>
           </p:cNvSpPr>
@@ -2136,8 +1950,8 @@
         </p:nvSpPr>
         <p:spPr>
           <a:xfrm>
-            <a:off x="6172200" y="1681163"/>
-            <a:ext cx="5183188" cy="823912"/>
+            <a:off x="4629150" y="1681163"/>
+            <a:ext cx="3887391" cy="823912"/>
           </a:xfrm>
         </p:spPr>
         <p:txBody>
@@ -2191,13 +2005,7 @@
       </p:sp>
       <p:sp>
         <p:nvSpPr>
-          <p:cNvPr id="6" name="Espace réservé du contenu 5">
-            <a:extLst>
-              <a:ext uri="{FF2B5EF4-FFF2-40B4-BE49-F238E27FC236}">
-                <a16:creationId xmlns:a16="http://schemas.microsoft.com/office/drawing/2014/main" id="{8F05E9F1-99DC-147B-179A-D09ECBD2485F}"/>
-              </a:ext>
-            </a:extLst>
-          </p:cNvPr>
+          <p:cNvPr id="6" name="Content Placeholder 5"/>
           <p:cNvSpPr>
             <a:spLocks noGrp="1"/>
           </p:cNvSpPr>
@@ -2207,8 +2015,8 @@
         </p:nvSpPr>
         <p:spPr>
           <a:xfrm>
-            <a:off x="6172200" y="2505075"/>
-            <a:ext cx="5183188" cy="3684588"/>
+            <a:off x="4629150" y="2505075"/>
+            <a:ext cx="3887391" cy="3684588"/>
           </a:xfrm>
         </p:spPr>
         <p:txBody>
@@ -2248,18 +2056,13 @@
               <a:rPr lang="fr-FR"/>
               <a:t>Cinquième niveau</a:t>
             </a:r>
-          </a:p>
-        </p:txBody>
-      </p:sp>
-      <p:sp>
-        <p:nvSpPr>
-          <p:cNvPr id="7" name="Espace réservé de la date 6">
-            <a:extLst>
-              <a:ext uri="{FF2B5EF4-FFF2-40B4-BE49-F238E27FC236}">
-                <a16:creationId xmlns:a16="http://schemas.microsoft.com/office/drawing/2014/main" id="{B94757C0-A699-E8A2-2D19-B3BA68996B81}"/>
-              </a:ext>
-            </a:extLst>
-          </p:cNvPr>
+            <a:endParaRPr lang="en-US" dirty="0"/>
+          </a:p>
+        </p:txBody>
+      </p:sp>
+      <p:sp>
+        <p:nvSpPr>
+          <p:cNvPr id="7" name="Date Placeholder 6"/>
           <p:cNvSpPr>
             <a:spLocks noGrp="1"/>
           </p:cNvSpPr>
@@ -2274,7 +2077,7 @@
           <a:p>
             <a:fld id="{5511EBAF-3E89-4224-B894-EF8FC8703D29}" type="datetimeFigureOut">
               <a:rPr lang="fr-FR" smtClean="0"/>
-              <a:t>07/04/2026</a:t>
+              <a:t>08/04/2026</a:t>
             </a:fld>
             <a:endParaRPr lang="fr-FR"/>
           </a:p>
@@ -2282,13 +2085,7 @@
       </p:sp>
       <p:sp>
         <p:nvSpPr>
-          <p:cNvPr id="8" name="Espace réservé du pied de page 7">
-            <a:extLst>
-              <a:ext uri="{FF2B5EF4-FFF2-40B4-BE49-F238E27FC236}">
-                <a16:creationId xmlns:a16="http://schemas.microsoft.com/office/drawing/2014/main" id="{E01AB11F-86DA-C66E-0539-FF13603908C0}"/>
-              </a:ext>
-            </a:extLst>
-          </p:cNvPr>
+          <p:cNvPr id="8" name="Footer Placeholder 7"/>
           <p:cNvSpPr>
             <a:spLocks noGrp="1"/>
           </p:cNvSpPr>
@@ -2307,13 +2104,7 @@
       </p:sp>
       <p:sp>
         <p:nvSpPr>
-          <p:cNvPr id="9" name="Espace réservé du numéro de diapositive 8">
-            <a:extLst>
-              <a:ext uri="{FF2B5EF4-FFF2-40B4-BE49-F238E27FC236}">
-                <a16:creationId xmlns:a16="http://schemas.microsoft.com/office/drawing/2014/main" id="{87285184-5B3B-2CD5-1164-71527D6C3F84}"/>
-              </a:ext>
-            </a:extLst>
-          </p:cNvPr>
+          <p:cNvPr id="9" name="Slide Number Placeholder 8"/>
           <p:cNvSpPr>
             <a:spLocks noGrp="1"/>
           </p:cNvSpPr>
@@ -2337,7 +2128,7 @@
     </p:spTree>
     <p:extLst>
       <p:ext uri="{BB962C8B-B14F-4D97-AF65-F5344CB8AC3E}">
-        <p14:creationId xmlns:p14="http://schemas.microsoft.com/office/powerpoint/2010/main" val="753960493"/>
+        <p14:creationId xmlns:p14="http://schemas.microsoft.com/office/powerpoint/2010/main" val="384658183"/>
       </p:ext>
     </p:extLst>
   </p:cSld>
@@ -2366,13 +2157,7 @@
       </p:grpSpPr>
       <p:sp>
         <p:nvSpPr>
-          <p:cNvPr id="2" name="Titre 1">
-            <a:extLst>
-              <a:ext uri="{FF2B5EF4-FFF2-40B4-BE49-F238E27FC236}">
-                <a16:creationId xmlns:a16="http://schemas.microsoft.com/office/drawing/2014/main" id="{B73A72DD-CE5F-52B7-BD3B-9AD3FD463A2F}"/>
-              </a:ext>
-            </a:extLst>
-          </p:cNvPr>
+          <p:cNvPr id="2" name="Title 1"/>
           <p:cNvSpPr>
             <a:spLocks noGrp="1"/>
           </p:cNvSpPr>
@@ -2389,18 +2174,13 @@
               <a:rPr lang="fr-FR"/>
               <a:t>Modifiez le style du titre</a:t>
             </a:r>
-          </a:p>
-        </p:txBody>
-      </p:sp>
-      <p:sp>
-        <p:nvSpPr>
-          <p:cNvPr id="3" name="Espace réservé de la date 2">
-            <a:extLst>
-              <a:ext uri="{FF2B5EF4-FFF2-40B4-BE49-F238E27FC236}">
-                <a16:creationId xmlns:a16="http://schemas.microsoft.com/office/drawing/2014/main" id="{5E879765-2812-0941-C484-B4D5B3420F01}"/>
-              </a:ext>
-            </a:extLst>
-          </p:cNvPr>
+            <a:endParaRPr lang="en-US" dirty="0"/>
+          </a:p>
+        </p:txBody>
+      </p:sp>
+      <p:sp>
+        <p:nvSpPr>
+          <p:cNvPr id="3" name="Date Placeholder 2"/>
           <p:cNvSpPr>
             <a:spLocks noGrp="1"/>
           </p:cNvSpPr>
@@ -2415,7 +2195,7 @@
           <a:p>
             <a:fld id="{5511EBAF-3E89-4224-B894-EF8FC8703D29}" type="datetimeFigureOut">
               <a:rPr lang="fr-FR" smtClean="0"/>
-              <a:t>07/04/2026</a:t>
+              <a:t>08/04/2026</a:t>
             </a:fld>
             <a:endParaRPr lang="fr-FR"/>
           </a:p>
@@ -2423,13 +2203,7 @@
       </p:sp>
       <p:sp>
         <p:nvSpPr>
-          <p:cNvPr id="4" name="Espace réservé du pied de page 3">
-            <a:extLst>
-              <a:ext uri="{FF2B5EF4-FFF2-40B4-BE49-F238E27FC236}">
-                <a16:creationId xmlns:a16="http://schemas.microsoft.com/office/drawing/2014/main" id="{DFCF6739-D109-E782-F45B-B77D1FFA1E94}"/>
-              </a:ext>
-            </a:extLst>
-          </p:cNvPr>
+          <p:cNvPr id="4" name="Footer Placeholder 3"/>
           <p:cNvSpPr>
             <a:spLocks noGrp="1"/>
           </p:cNvSpPr>
@@ -2448,13 +2222,7 @@
       </p:sp>
       <p:sp>
         <p:nvSpPr>
-          <p:cNvPr id="5" name="Espace réservé du numéro de diapositive 4">
-            <a:extLst>
-              <a:ext uri="{FF2B5EF4-FFF2-40B4-BE49-F238E27FC236}">
-                <a16:creationId xmlns:a16="http://schemas.microsoft.com/office/drawing/2014/main" id="{C3FFEEF7-1C15-C40D-C606-E1F385BE1537}"/>
-              </a:ext>
-            </a:extLst>
-          </p:cNvPr>
+          <p:cNvPr id="5" name="Slide Number Placeholder 4"/>
           <p:cNvSpPr>
             <a:spLocks noGrp="1"/>
           </p:cNvSpPr>
@@ -2478,7 +2246,7 @@
     </p:spTree>
     <p:extLst>
       <p:ext uri="{BB962C8B-B14F-4D97-AF65-F5344CB8AC3E}">
-        <p14:creationId xmlns:p14="http://schemas.microsoft.com/office/powerpoint/2010/main" val="822159713"/>
+        <p14:creationId xmlns:p14="http://schemas.microsoft.com/office/powerpoint/2010/main" val="184903403"/>
       </p:ext>
     </p:extLst>
   </p:cSld>
@@ -2507,13 +2275,7 @@
       </p:grpSpPr>
       <p:sp>
         <p:nvSpPr>
-          <p:cNvPr id="2" name="Espace réservé de la date 1">
-            <a:extLst>
-              <a:ext uri="{FF2B5EF4-FFF2-40B4-BE49-F238E27FC236}">
-                <a16:creationId xmlns:a16="http://schemas.microsoft.com/office/drawing/2014/main" id="{EA2BE1E8-A1EC-2C47-9373-9078B43BA648}"/>
-              </a:ext>
-            </a:extLst>
-          </p:cNvPr>
+          <p:cNvPr id="2" name="Date Placeholder 1"/>
           <p:cNvSpPr>
             <a:spLocks noGrp="1"/>
           </p:cNvSpPr>
@@ -2528,7 +2290,7 @@
           <a:p>
             <a:fld id="{5511EBAF-3E89-4224-B894-EF8FC8703D29}" type="datetimeFigureOut">
               <a:rPr lang="fr-FR" smtClean="0"/>
-              <a:t>07/04/2026</a:t>
+              <a:t>08/04/2026</a:t>
             </a:fld>
             <a:endParaRPr lang="fr-FR"/>
           </a:p>
@@ -2536,13 +2298,7 @@
       </p:sp>
       <p:sp>
         <p:nvSpPr>
-          <p:cNvPr id="3" name="Espace réservé du pied de page 2">
-            <a:extLst>
-              <a:ext uri="{FF2B5EF4-FFF2-40B4-BE49-F238E27FC236}">
-                <a16:creationId xmlns:a16="http://schemas.microsoft.com/office/drawing/2014/main" id="{8BD3BDCF-1B6A-40AF-DFE9-BEAC154C4B21}"/>
-              </a:ext>
-            </a:extLst>
-          </p:cNvPr>
+          <p:cNvPr id="3" name="Footer Placeholder 2"/>
           <p:cNvSpPr>
             <a:spLocks noGrp="1"/>
           </p:cNvSpPr>
@@ -2561,13 +2317,7 @@
       </p:sp>
       <p:sp>
         <p:nvSpPr>
-          <p:cNvPr id="4" name="Espace réservé du numéro de diapositive 3">
-            <a:extLst>
-              <a:ext uri="{FF2B5EF4-FFF2-40B4-BE49-F238E27FC236}">
-                <a16:creationId xmlns:a16="http://schemas.microsoft.com/office/drawing/2014/main" id="{20EDBD25-C9B7-D53C-408A-F1B4AB990249}"/>
-              </a:ext>
-            </a:extLst>
-          </p:cNvPr>
+          <p:cNvPr id="4" name="Slide Number Placeholder 3"/>
           <p:cNvSpPr>
             <a:spLocks noGrp="1"/>
           </p:cNvSpPr>
@@ -2591,7 +2341,7 @@
     </p:spTree>
     <p:extLst>
       <p:ext uri="{BB962C8B-B14F-4D97-AF65-F5344CB8AC3E}">
-        <p14:creationId xmlns:p14="http://schemas.microsoft.com/office/powerpoint/2010/main" val="681255363"/>
+        <p14:creationId xmlns:p14="http://schemas.microsoft.com/office/powerpoint/2010/main" val="2066735277"/>
       </p:ext>
     </p:extLst>
   </p:cSld>
@@ -2620,13 +2370,7 @@
       </p:grpSpPr>
       <p:sp>
         <p:nvSpPr>
-          <p:cNvPr id="2" name="Titre 1">
-            <a:extLst>
-              <a:ext uri="{FF2B5EF4-FFF2-40B4-BE49-F238E27FC236}">
-                <a16:creationId xmlns:a16="http://schemas.microsoft.com/office/drawing/2014/main" id="{4DDB8E19-787C-A81B-4E97-A0D0A07D146A}"/>
-              </a:ext>
-            </a:extLst>
-          </p:cNvPr>
+          <p:cNvPr id="2" name="Title 1"/>
           <p:cNvSpPr>
             <a:spLocks noGrp="1"/>
           </p:cNvSpPr>
@@ -2636,8 +2380,8 @@
         </p:nvSpPr>
         <p:spPr>
           <a:xfrm>
-            <a:off x="839788" y="457200"/>
-            <a:ext cx="3932237" cy="1600200"/>
+            <a:off x="629841" y="457200"/>
+            <a:ext cx="2949178" cy="1600200"/>
           </a:xfrm>
         </p:spPr>
         <p:txBody>
@@ -2652,18 +2396,13 @@
               <a:rPr lang="fr-FR"/>
               <a:t>Modifiez le style du titre</a:t>
             </a:r>
-          </a:p>
-        </p:txBody>
-      </p:sp>
-      <p:sp>
-        <p:nvSpPr>
-          <p:cNvPr id="3" name="Espace réservé du contenu 2">
-            <a:extLst>
-              <a:ext uri="{FF2B5EF4-FFF2-40B4-BE49-F238E27FC236}">
-                <a16:creationId xmlns:a16="http://schemas.microsoft.com/office/drawing/2014/main" id="{7656F0BA-E27C-21B3-FC75-DAC7FA80F7CC}"/>
-              </a:ext>
-            </a:extLst>
-          </p:cNvPr>
+            <a:endParaRPr lang="en-US" dirty="0"/>
+          </a:p>
+        </p:txBody>
+      </p:sp>
+      <p:sp>
+        <p:nvSpPr>
+          <p:cNvPr id="3" name="Content Placeholder 2"/>
           <p:cNvSpPr>
             <a:spLocks noGrp="1"/>
           </p:cNvSpPr>
@@ -2673,8 +2412,8 @@
         </p:nvSpPr>
         <p:spPr>
           <a:xfrm>
-            <a:off x="5183188" y="987425"/>
-            <a:ext cx="6172200" cy="4873625"/>
+            <a:off x="3887391" y="987426"/>
+            <a:ext cx="4629150" cy="4873625"/>
           </a:xfrm>
         </p:spPr>
         <p:txBody>
@@ -2742,18 +2481,13 @@
               <a:rPr lang="fr-FR"/>
               <a:t>Cinquième niveau</a:t>
             </a:r>
-          </a:p>
-        </p:txBody>
-      </p:sp>
-      <p:sp>
-        <p:nvSpPr>
-          <p:cNvPr id="4" name="Espace réservé du texte 3">
-            <a:extLst>
-              <a:ext uri="{FF2B5EF4-FFF2-40B4-BE49-F238E27FC236}">
-                <a16:creationId xmlns:a16="http://schemas.microsoft.com/office/drawing/2014/main" id="{AAE43FCD-9715-8452-5250-956F565DE22B}"/>
-              </a:ext>
-            </a:extLst>
-          </p:cNvPr>
+            <a:endParaRPr lang="en-US" dirty="0"/>
+          </a:p>
+        </p:txBody>
+      </p:sp>
+      <p:sp>
+        <p:nvSpPr>
+          <p:cNvPr id="4" name="Text Placeholder 3"/>
           <p:cNvSpPr>
             <a:spLocks noGrp="1"/>
           </p:cNvSpPr>
@@ -2763,8 +2497,8 @@
         </p:nvSpPr>
         <p:spPr>
           <a:xfrm>
-            <a:off x="839788" y="2057400"/>
-            <a:ext cx="3932237" cy="3811588"/>
+            <a:off x="629841" y="2057400"/>
+            <a:ext cx="2949178" cy="3811588"/>
           </a:xfrm>
         </p:spPr>
         <p:txBody>
@@ -2818,13 +2552,7 @@
       </p:sp>
       <p:sp>
         <p:nvSpPr>
-          <p:cNvPr id="5" name="Espace réservé de la date 4">
-            <a:extLst>
-              <a:ext uri="{FF2B5EF4-FFF2-40B4-BE49-F238E27FC236}">
-                <a16:creationId xmlns:a16="http://schemas.microsoft.com/office/drawing/2014/main" id="{3472F0BB-F2AF-2B0F-1803-E31A47C38AB7}"/>
-              </a:ext>
-            </a:extLst>
-          </p:cNvPr>
+          <p:cNvPr id="5" name="Date Placeholder 4"/>
           <p:cNvSpPr>
             <a:spLocks noGrp="1"/>
           </p:cNvSpPr>
@@ -2839,7 +2567,7 @@
           <a:p>
             <a:fld id="{5511EBAF-3E89-4224-B894-EF8FC8703D29}" type="datetimeFigureOut">
               <a:rPr lang="fr-FR" smtClean="0"/>
-              <a:t>07/04/2026</a:t>
+              <a:t>08/04/2026</a:t>
             </a:fld>
             <a:endParaRPr lang="fr-FR"/>
           </a:p>
@@ -2847,13 +2575,7 @@
       </p:sp>
       <p:sp>
         <p:nvSpPr>
-          <p:cNvPr id="6" name="Espace réservé du pied de page 5">
-            <a:extLst>
-              <a:ext uri="{FF2B5EF4-FFF2-40B4-BE49-F238E27FC236}">
-                <a16:creationId xmlns:a16="http://schemas.microsoft.com/office/drawing/2014/main" id="{081B23ED-65D2-5ABE-7ADA-9A74D08AD5D5}"/>
-              </a:ext>
-            </a:extLst>
-          </p:cNvPr>
+          <p:cNvPr id="6" name="Footer Placeholder 5"/>
           <p:cNvSpPr>
             <a:spLocks noGrp="1"/>
           </p:cNvSpPr>
@@ -2872,13 +2594,7 @@
       </p:sp>
       <p:sp>
         <p:nvSpPr>
-          <p:cNvPr id="7" name="Espace réservé du numéro de diapositive 6">
-            <a:extLst>
-              <a:ext uri="{FF2B5EF4-FFF2-40B4-BE49-F238E27FC236}">
-                <a16:creationId xmlns:a16="http://schemas.microsoft.com/office/drawing/2014/main" id="{11091459-6ABF-B2DF-9B46-76BECCD016C3}"/>
-              </a:ext>
-            </a:extLst>
-          </p:cNvPr>
+          <p:cNvPr id="7" name="Slide Number Placeholder 6"/>
           <p:cNvSpPr>
             <a:spLocks noGrp="1"/>
           </p:cNvSpPr>
@@ -2902,7 +2618,7 @@
     </p:spTree>
     <p:extLst>
       <p:ext uri="{BB962C8B-B14F-4D97-AF65-F5344CB8AC3E}">
-        <p14:creationId xmlns:p14="http://schemas.microsoft.com/office/powerpoint/2010/main" val="245518893"/>
+        <p14:creationId xmlns:p14="http://schemas.microsoft.com/office/powerpoint/2010/main" val="1538460854"/>
       </p:ext>
     </p:extLst>
   </p:cSld>
@@ -2931,13 +2647,7 @@
       </p:grpSpPr>
       <p:sp>
         <p:nvSpPr>
-          <p:cNvPr id="2" name="Titre 1">
-            <a:extLst>
-              <a:ext uri="{FF2B5EF4-FFF2-40B4-BE49-F238E27FC236}">
-                <a16:creationId xmlns:a16="http://schemas.microsoft.com/office/drawing/2014/main" id="{27808C95-2081-CB8B-5D05-6BDDC588EFFB}"/>
-              </a:ext>
-            </a:extLst>
-          </p:cNvPr>
+          <p:cNvPr id="2" name="Title 1"/>
           <p:cNvSpPr>
             <a:spLocks noGrp="1"/>
           </p:cNvSpPr>
@@ -2947,8 +2657,8 @@
         </p:nvSpPr>
         <p:spPr>
           <a:xfrm>
-            <a:off x="839788" y="457200"/>
-            <a:ext cx="3932237" cy="1600200"/>
+            <a:off x="629841" y="457200"/>
+            <a:ext cx="2949178" cy="1600200"/>
           </a:xfrm>
         </p:spPr>
         <p:txBody>
@@ -2963,20 +2673,15 @@
               <a:rPr lang="fr-FR"/>
               <a:t>Modifiez le style du titre</a:t>
             </a:r>
-          </a:p>
-        </p:txBody>
-      </p:sp>
-      <p:sp>
-        <p:nvSpPr>
-          <p:cNvPr id="3" name="Espace réservé pour une image  2">
-            <a:extLst>
-              <a:ext uri="{FF2B5EF4-FFF2-40B4-BE49-F238E27FC236}">
-                <a16:creationId xmlns:a16="http://schemas.microsoft.com/office/drawing/2014/main" id="{C9D4982A-D8A3-EB40-8B88-97B35734BAF4}"/>
-              </a:ext>
-            </a:extLst>
-          </p:cNvPr>
-          <p:cNvSpPr>
-            <a:spLocks noGrp="1"/>
+            <a:endParaRPr lang="en-US" dirty="0"/>
+          </a:p>
+        </p:txBody>
+      </p:sp>
+      <p:sp>
+        <p:nvSpPr>
+          <p:cNvPr id="3" name="Picture Placeholder 2"/>
+          <p:cNvSpPr>
+            <a:spLocks noGrp="1" noChangeAspect="1"/>
           </p:cNvSpPr>
           <p:nvPr>
             <p:ph type="pic" idx="1"/>
@@ -2984,12 +2689,12 @@
         </p:nvSpPr>
         <p:spPr>
           <a:xfrm>
-            <a:off x="5183188" y="987425"/>
-            <a:ext cx="6172200" cy="4873625"/>
+            <a:off x="3887391" y="987426"/>
+            <a:ext cx="4629150" cy="4873625"/>
           </a:xfrm>
         </p:spPr>
         <p:txBody>
-          <a:bodyPr/>
+          <a:bodyPr anchor="t"/>
           <a:lstStyle>
             <a:lvl1pPr marL="0" indent="0">
               <a:buNone/>
@@ -3029,19 +2734,17 @@
             </a:lvl9pPr>
           </a:lstStyle>
           <a:p>
-            <a:endParaRPr lang="fr-FR"/>
-          </a:p>
-        </p:txBody>
-      </p:sp>
-      <p:sp>
-        <p:nvSpPr>
-          <p:cNvPr id="4" name="Espace réservé du texte 3">
-            <a:extLst>
-              <a:ext uri="{FF2B5EF4-FFF2-40B4-BE49-F238E27FC236}">
-                <a16:creationId xmlns:a16="http://schemas.microsoft.com/office/drawing/2014/main" id="{0E56968C-7338-0A86-727D-6A55944CFC1E}"/>
-              </a:ext>
-            </a:extLst>
-          </p:cNvPr>
+            <a:r>
+              <a:rPr lang="fr-FR"/>
+              <a:t>Cliquez sur l'icône pour ajouter une image</a:t>
+            </a:r>
+            <a:endParaRPr lang="en-US" dirty="0"/>
+          </a:p>
+        </p:txBody>
+      </p:sp>
+      <p:sp>
+        <p:nvSpPr>
+          <p:cNvPr id="4" name="Text Placeholder 3"/>
           <p:cNvSpPr>
             <a:spLocks noGrp="1"/>
           </p:cNvSpPr>
@@ -3051,8 +2754,8 @@
         </p:nvSpPr>
         <p:spPr>
           <a:xfrm>
-            <a:off x="839788" y="2057400"/>
-            <a:ext cx="3932237" cy="3811588"/>
+            <a:off x="629841" y="2057400"/>
+            <a:ext cx="2949178" cy="3811588"/>
           </a:xfrm>
         </p:spPr>
         <p:txBody>
@@ -3106,13 +2809,7 @@
       </p:sp>
       <p:sp>
         <p:nvSpPr>
-          <p:cNvPr id="5" name="Espace réservé de la date 4">
-            <a:extLst>
-              <a:ext uri="{FF2B5EF4-FFF2-40B4-BE49-F238E27FC236}">
-                <a16:creationId xmlns:a16="http://schemas.microsoft.com/office/drawing/2014/main" id="{4DB38773-7B43-645C-2E0E-CAF9AFE0BE16}"/>
-              </a:ext>
-            </a:extLst>
-          </p:cNvPr>
+          <p:cNvPr id="5" name="Date Placeholder 4"/>
           <p:cNvSpPr>
             <a:spLocks noGrp="1"/>
           </p:cNvSpPr>
@@ -3127,7 +2824,7 @@
           <a:p>
             <a:fld id="{5511EBAF-3E89-4224-B894-EF8FC8703D29}" type="datetimeFigureOut">
               <a:rPr lang="fr-FR" smtClean="0"/>
-              <a:t>07/04/2026</a:t>
+              <a:t>08/04/2026</a:t>
             </a:fld>
             <a:endParaRPr lang="fr-FR"/>
           </a:p>
@@ -3135,13 +2832,7 @@
       </p:sp>
       <p:sp>
         <p:nvSpPr>
-          <p:cNvPr id="6" name="Espace réservé du pied de page 5">
-            <a:extLst>
-              <a:ext uri="{FF2B5EF4-FFF2-40B4-BE49-F238E27FC236}">
-                <a16:creationId xmlns:a16="http://schemas.microsoft.com/office/drawing/2014/main" id="{E8B0B539-F817-6A3B-371A-BE055E33482B}"/>
-              </a:ext>
-            </a:extLst>
-          </p:cNvPr>
+          <p:cNvPr id="6" name="Footer Placeholder 5"/>
           <p:cNvSpPr>
             <a:spLocks noGrp="1"/>
           </p:cNvSpPr>
@@ -3160,13 +2851,7 @@
       </p:sp>
       <p:sp>
         <p:nvSpPr>
-          <p:cNvPr id="7" name="Espace réservé du numéro de diapositive 6">
-            <a:extLst>
-              <a:ext uri="{FF2B5EF4-FFF2-40B4-BE49-F238E27FC236}">
-                <a16:creationId xmlns:a16="http://schemas.microsoft.com/office/drawing/2014/main" id="{B9C67A0E-9A29-553A-54CB-76562F0376C6}"/>
-              </a:ext>
-            </a:extLst>
-          </p:cNvPr>
+          <p:cNvPr id="7" name="Slide Number Placeholder 6"/>
           <p:cNvSpPr>
             <a:spLocks noGrp="1"/>
           </p:cNvSpPr>
@@ -3190,7 +2875,7 @@
     </p:spTree>
     <p:extLst>
       <p:ext uri="{BB962C8B-B14F-4D97-AF65-F5344CB8AC3E}">
-        <p14:creationId xmlns:p14="http://schemas.microsoft.com/office/powerpoint/2010/main" val="1822079711"/>
+        <p14:creationId xmlns:p14="http://schemas.microsoft.com/office/powerpoint/2010/main" val="3739415903"/>
       </p:ext>
     </p:extLst>
   </p:cSld>
@@ -3224,13 +2909,7 @@
       </p:grpSpPr>
       <p:sp>
         <p:nvSpPr>
-          <p:cNvPr id="2" name="Espace réservé du titre 1">
-            <a:extLst>
-              <a:ext uri="{FF2B5EF4-FFF2-40B4-BE49-F238E27FC236}">
-                <a16:creationId xmlns:a16="http://schemas.microsoft.com/office/drawing/2014/main" id="{81EF9374-375C-CF79-614B-85061254C297}"/>
-              </a:ext>
-            </a:extLst>
-          </p:cNvPr>
+          <p:cNvPr id="2" name="Title Placeholder 1"/>
           <p:cNvSpPr>
             <a:spLocks noGrp="1"/>
           </p:cNvSpPr>
@@ -3240,8 +2919,8 @@
         </p:nvSpPr>
         <p:spPr>
           <a:xfrm>
-            <a:off x="838200" y="365125"/>
-            <a:ext cx="10515600" cy="1325563"/>
+            <a:off x="628650" y="365126"/>
+            <a:ext cx="7886700" cy="1325563"/>
           </a:xfrm>
           <a:prstGeom prst="rect">
             <a:avLst/>
@@ -3257,18 +2936,13 @@
               <a:rPr lang="fr-FR"/>
               <a:t>Modifiez le style du titre</a:t>
             </a:r>
-          </a:p>
-        </p:txBody>
-      </p:sp>
-      <p:sp>
-        <p:nvSpPr>
-          <p:cNvPr id="3" name="Espace réservé du texte 2">
-            <a:extLst>
-              <a:ext uri="{FF2B5EF4-FFF2-40B4-BE49-F238E27FC236}">
-                <a16:creationId xmlns:a16="http://schemas.microsoft.com/office/drawing/2014/main" id="{715D79A4-F0B6-18E6-716A-14C101AC6FA4}"/>
-              </a:ext>
-            </a:extLst>
-          </p:cNvPr>
+            <a:endParaRPr lang="en-US" dirty="0"/>
+          </a:p>
+        </p:txBody>
+      </p:sp>
+      <p:sp>
+        <p:nvSpPr>
+          <p:cNvPr id="3" name="Text Placeholder 2"/>
           <p:cNvSpPr>
             <a:spLocks noGrp="1"/>
           </p:cNvSpPr>
@@ -3278,8 +2952,8 @@
         </p:nvSpPr>
         <p:spPr>
           <a:xfrm>
-            <a:off x="838200" y="1825625"/>
-            <a:ext cx="10515600" cy="4351338"/>
+            <a:off x="628650" y="1825625"/>
+            <a:ext cx="7886700" cy="4351338"/>
           </a:xfrm>
           <a:prstGeom prst="rect">
             <a:avLst/>
@@ -3324,18 +2998,13 @@
               <a:rPr lang="fr-FR"/>
               <a:t>Cinquième niveau</a:t>
             </a:r>
-          </a:p>
-        </p:txBody>
-      </p:sp>
-      <p:sp>
-        <p:nvSpPr>
-          <p:cNvPr id="4" name="Espace réservé de la date 3">
-            <a:extLst>
-              <a:ext uri="{FF2B5EF4-FFF2-40B4-BE49-F238E27FC236}">
-                <a16:creationId xmlns:a16="http://schemas.microsoft.com/office/drawing/2014/main" id="{D86D6F5E-D988-953A-E0F2-2C1C416E6FC5}"/>
-              </a:ext>
-            </a:extLst>
-          </p:cNvPr>
+            <a:endParaRPr lang="en-US" dirty="0"/>
+          </a:p>
+        </p:txBody>
+      </p:sp>
+      <p:sp>
+        <p:nvSpPr>
+          <p:cNvPr id="4" name="Date Placeholder 3"/>
           <p:cNvSpPr>
             <a:spLocks noGrp="1"/>
           </p:cNvSpPr>
@@ -3345,8 +3014,8 @@
         </p:nvSpPr>
         <p:spPr>
           <a:xfrm>
-            <a:off x="838200" y="6356350"/>
-            <a:ext cx="2743200" cy="365125"/>
+            <a:off x="628650" y="6356351"/>
+            <a:ext cx="2057400" cy="365125"/>
           </a:xfrm>
           <a:prstGeom prst="rect">
             <a:avLst/>
@@ -3368,7 +3037,7 @@
           <a:p>
             <a:fld id="{5511EBAF-3E89-4224-B894-EF8FC8703D29}" type="datetimeFigureOut">
               <a:rPr lang="fr-FR" smtClean="0"/>
-              <a:t>07/04/2026</a:t>
+              <a:t>08/04/2026</a:t>
             </a:fld>
             <a:endParaRPr lang="fr-FR"/>
           </a:p>
@@ -3376,13 +3045,7 @@
       </p:sp>
       <p:sp>
         <p:nvSpPr>
-          <p:cNvPr id="5" name="Espace réservé du pied de page 4">
-            <a:extLst>
-              <a:ext uri="{FF2B5EF4-FFF2-40B4-BE49-F238E27FC236}">
-                <a16:creationId xmlns:a16="http://schemas.microsoft.com/office/drawing/2014/main" id="{DE9D51B4-1F9E-DF3C-AA7B-A0D1A2268308}"/>
-              </a:ext>
-            </a:extLst>
-          </p:cNvPr>
+          <p:cNvPr id="5" name="Footer Placeholder 4"/>
           <p:cNvSpPr>
             <a:spLocks noGrp="1"/>
           </p:cNvSpPr>
@@ -3392,8 +3055,8 @@
         </p:nvSpPr>
         <p:spPr>
           <a:xfrm>
-            <a:off x="4038600" y="6356350"/>
-            <a:ext cx="4114800" cy="365125"/>
+            <a:off x="3028950" y="6356351"/>
+            <a:ext cx="3086100" cy="365125"/>
           </a:xfrm>
           <a:prstGeom prst="rect">
             <a:avLst/>
@@ -3419,13 +3082,7 @@
       </p:sp>
       <p:sp>
         <p:nvSpPr>
-          <p:cNvPr id="6" name="Espace réservé du numéro de diapositive 5">
-            <a:extLst>
-              <a:ext uri="{FF2B5EF4-FFF2-40B4-BE49-F238E27FC236}">
-                <a16:creationId xmlns:a16="http://schemas.microsoft.com/office/drawing/2014/main" id="{4946BA47-43E8-992B-679C-E9061BF3EFE2}"/>
-              </a:ext>
-            </a:extLst>
-          </p:cNvPr>
+          <p:cNvPr id="6" name="Slide Number Placeholder 5"/>
           <p:cNvSpPr>
             <a:spLocks noGrp="1"/>
           </p:cNvSpPr>
@@ -3435,8 +3092,8 @@
         </p:nvSpPr>
         <p:spPr>
           <a:xfrm>
-            <a:off x="8610600" y="6356350"/>
-            <a:ext cx="2743200" cy="365125"/>
+            <a:off x="6457950" y="6356351"/>
+            <a:ext cx="2057400" cy="365125"/>
           </a:xfrm>
           <a:prstGeom prst="rect">
             <a:avLst/>
@@ -3467,23 +3124,23 @@
     </p:spTree>
     <p:extLst>
       <p:ext uri="{BB962C8B-B14F-4D97-AF65-F5344CB8AC3E}">
-        <p14:creationId xmlns:p14="http://schemas.microsoft.com/office/powerpoint/2010/main" val="4074393099"/>
+        <p14:creationId xmlns:p14="http://schemas.microsoft.com/office/powerpoint/2010/main" val="1203588177"/>
       </p:ext>
     </p:extLst>
   </p:cSld>
   <p:clrMap bg1="lt1" tx1="dk1" bg2="lt2" tx2="dk2" accent1="accent1" accent2="accent2" accent3="accent3" accent4="accent4" accent5="accent5" accent6="accent6" hlink="hlink" folHlink="folHlink"/>
   <p:sldLayoutIdLst>
-    <p:sldLayoutId id="2147483649" r:id="rId1"/>
-    <p:sldLayoutId id="2147483650" r:id="rId2"/>
-    <p:sldLayoutId id="2147483651" r:id="rId3"/>
-    <p:sldLayoutId id="2147483652" r:id="rId4"/>
-    <p:sldLayoutId id="2147483653" r:id="rId5"/>
-    <p:sldLayoutId id="2147483654" r:id="rId6"/>
-    <p:sldLayoutId id="2147483655" r:id="rId7"/>
-    <p:sldLayoutId id="2147483656" r:id="rId8"/>
-    <p:sldLayoutId id="2147483657" r:id="rId9"/>
-    <p:sldLayoutId id="2147483658" r:id="rId10"/>
-    <p:sldLayoutId id="2147483659" r:id="rId11"/>
+    <p:sldLayoutId id="2147483661" r:id="rId1"/>
+    <p:sldLayoutId id="2147483662" r:id="rId2"/>
+    <p:sldLayoutId id="2147483663" r:id="rId3"/>
+    <p:sldLayoutId id="2147483664" r:id="rId4"/>
+    <p:sldLayoutId id="2147483665" r:id="rId5"/>
+    <p:sldLayoutId id="2147483666" r:id="rId6"/>
+    <p:sldLayoutId id="2147483667" r:id="rId7"/>
+    <p:sldLayoutId id="2147483668" r:id="rId8"/>
+    <p:sldLayoutId id="2147483669" r:id="rId9"/>
+    <p:sldLayoutId id="2147483670" r:id="rId10"/>
+    <p:sldLayoutId id="2147483671" r:id="rId11"/>
   </p:sldLayoutIdLst>
   <p:txStyles>
     <p:titleStyle>
@@ -3671,7 +3328,7 @@
     </p:bodyStyle>
     <p:otherStyle>
       <a:defPPr>
-        <a:defRPr lang="fr-FR"/>
+        <a:defRPr lang="en-US"/>
       </a:defPPr>
       <a:lvl1pPr marL="0" algn="l" defTabSz="914400" rtl="0" eaLnBrk="1" latinLnBrk="0" hangingPunct="1">
         <a:defRPr sz="1800" kern="1200">
@@ -3797,8 +3454,8 @@
         </p:nvSpPr>
         <p:spPr>
           <a:xfrm>
-            <a:off x="1524000" y="2725271"/>
-            <a:ext cx="8387510" cy="703729"/>
+            <a:off x="2" y="2725274"/>
+            <a:ext cx="8387511" cy="703729"/>
           </a:xfrm>
         </p:spPr>
         <p:txBody>
@@ -3877,8 +3534,8 @@
         </p:blipFill>
         <p:spPr>
           <a:xfrm>
-            <a:off x="1401715" y="-103244"/>
-            <a:ext cx="9282494" cy="2694043"/>
+            <a:off x="-122285" y="-103243"/>
+            <a:ext cx="9282495" cy="2694043"/>
           </a:xfrm>
           <a:prstGeom prst="rect">
             <a:avLst/>
@@ -3901,8 +3558,8 @@
         </p:nvSpPr>
         <p:spPr>
           <a:xfrm>
-            <a:off x="1524000" y="5284842"/>
-            <a:ext cx="9282493" cy="1541930"/>
+            <a:off x="1" y="5284842"/>
+            <a:ext cx="9282493" cy="1541931"/>
           </a:xfrm>
           <a:prstGeom prst="rect">
             <a:avLst/>
@@ -4025,8 +3682,8 @@
         </p:nvSpPr>
         <p:spPr>
           <a:xfrm>
-            <a:off x="411257" y="212724"/>
-            <a:ext cx="5020234" cy="523220"/>
+            <a:off x="-1112743" y="212724"/>
+            <a:ext cx="5020235" cy="523220"/>
           </a:xfrm>
           <a:prstGeom prst="rect">
             <a:avLst/>
@@ -4062,7 +3719,7 @@
         </p:nvSpPr>
         <p:spPr>
           <a:xfrm>
-            <a:off x="1362075" y="1935068"/>
+            <a:off x="-161923" y="1935070"/>
             <a:ext cx="9307607" cy="2246769"/>
           </a:xfrm>
           <a:prstGeom prst="rect">
@@ -4076,7 +3733,7 @@
           </a:bodyPr>
           <a:lstStyle/>
           <a:p>
-            <a:pPr marL="457200" indent="-457200">
+            <a:pPr marL="457189" indent="-457189">
               <a:buFont typeface="Arial" panose="020B0604020202020204" pitchFamily="34" charset="0"/>
               <a:buChar char="•"/>
             </a:pPr>
@@ -4088,7 +3745,7 @@
             </a:r>
           </a:p>
           <a:p>
-            <a:pPr marL="457200" indent="-457200">
+            <a:pPr marL="457189" indent="-457189">
               <a:buFont typeface="Arial" panose="020B0604020202020204" pitchFamily="34" charset="0"/>
               <a:buChar char="•"/>
             </a:pPr>
@@ -4097,7 +3754,7 @@
             </a:endParaRPr>
           </a:p>
           <a:p>
-            <a:pPr marL="457200" indent="-457200">
+            <a:pPr marL="457189" indent="-457189">
               <a:buFont typeface="Arial" panose="020B0604020202020204" pitchFamily="34" charset="0"/>
               <a:buChar char="•"/>
             </a:pPr>
@@ -4109,7 +3766,7 @@
             </a:r>
           </a:p>
           <a:p>
-            <a:pPr marL="457200" indent="-457200">
+            <a:pPr marL="457189" indent="-457189">
               <a:buFont typeface="Arial" panose="020B0604020202020204" pitchFamily="34" charset="0"/>
               <a:buChar char="•"/>
             </a:pPr>
@@ -4118,7 +3775,7 @@
             </a:endParaRPr>
           </a:p>
           <a:p>
-            <a:pPr marL="457200" indent="-457200">
+            <a:pPr marL="457189" indent="-457189">
               <a:buFont typeface="Arial" panose="020B0604020202020204" pitchFamily="34" charset="0"/>
               <a:buChar char="•"/>
             </a:pPr>
@@ -4169,161 +3826,6 @@
           <a:chExt cx="0" cy="0"/>
         </a:xfrm>
       </p:grpSpPr>
-      <p:sp>
-        <p:nvSpPr>
-          <p:cNvPr id="9" name="Rectangle 8">
-            <a:extLst>
-              <a:ext uri="{FF2B5EF4-FFF2-40B4-BE49-F238E27FC236}">
-                <a16:creationId xmlns:a16="http://schemas.microsoft.com/office/drawing/2014/main" id="{42A4FC2C-047E-45A5-965D-8E1E3BF09BC6}"/>
-              </a:ext>
-              <a:ext uri="{C183D7F6-B498-43B3-948B-1728B52AA6E4}">
-                <adec:decorative xmlns:adec="http://schemas.microsoft.com/office/drawing/2017/decorative" val="1"/>
-              </a:ext>
-            </a:extLst>
-          </p:cNvPr>
-          <p:cNvSpPr>
-            <a:spLocks noGrp="1" noRot="1" noChangeAspect="1" noMove="1" noResize="1" noEditPoints="1" noAdjustHandles="1" noChangeArrowheads="1" noChangeShapeType="1" noTextEdit="1"/>
-          </p:cNvSpPr>
-          <p:nvPr>
-            <p:extLst>
-              <p:ext uri="{386F3935-93C4-4BCD-93E2-E3B085C9AB24}">
-                <p16:designElem xmlns:p16="http://schemas.microsoft.com/office/powerpoint/2015/main" val="1"/>
-              </p:ext>
-            </p:extLst>
-          </p:nvPr>
-        </p:nvSpPr>
-        <p:spPr bwMode="white">
-          <a:xfrm>
-            <a:off x="1524" y="0"/>
-            <a:ext cx="12188952" cy="6858000"/>
-          </a:xfrm>
-          <a:prstGeom prst="rect">
-            <a:avLst/>
-          </a:prstGeom>
-          <a:noFill/>
-          <a:ln>
-            <a:noFill/>
-          </a:ln>
-        </p:spPr>
-        <p:style>
-          <a:lnRef idx="2">
-            <a:schemeClr val="accent1">
-              <a:shade val="50000"/>
-            </a:schemeClr>
-          </a:lnRef>
-          <a:fillRef idx="1">
-            <a:schemeClr val="accent1"/>
-          </a:fillRef>
-          <a:effectRef idx="0">
-            <a:schemeClr val="accent1"/>
-          </a:effectRef>
-          <a:fontRef idx="minor">
-            <a:schemeClr val="lt1"/>
-          </a:fontRef>
-        </p:style>
-        <p:txBody>
-          <a:bodyPr rtlCol="0" anchor="ctr"/>
-          <a:lstStyle>
-            <a:defPPr>
-              <a:defRPr lang="en-US"/>
-            </a:defPPr>
-            <a:lvl1pPr marL="0" algn="l" defTabSz="914400" rtl="0" eaLnBrk="1" latinLnBrk="0" hangingPunct="1">
-              <a:defRPr sz="1800" kern="1200">
-                <a:solidFill>
-                  <a:schemeClr val="lt1"/>
-                </a:solidFill>
-                <a:latin typeface="+mn-lt"/>
-                <a:ea typeface="+mn-ea"/>
-                <a:cs typeface="+mn-cs"/>
-              </a:defRPr>
-            </a:lvl1pPr>
-            <a:lvl2pPr marL="457200" algn="l" defTabSz="914400" rtl="0" eaLnBrk="1" latinLnBrk="0" hangingPunct="1">
-              <a:defRPr sz="1800" kern="1200">
-                <a:solidFill>
-                  <a:schemeClr val="lt1"/>
-                </a:solidFill>
-                <a:latin typeface="+mn-lt"/>
-                <a:ea typeface="+mn-ea"/>
-                <a:cs typeface="+mn-cs"/>
-              </a:defRPr>
-            </a:lvl2pPr>
-            <a:lvl3pPr marL="914400" algn="l" defTabSz="914400" rtl="0" eaLnBrk="1" latinLnBrk="0" hangingPunct="1">
-              <a:defRPr sz="1800" kern="1200">
-                <a:solidFill>
-                  <a:schemeClr val="lt1"/>
-                </a:solidFill>
-                <a:latin typeface="+mn-lt"/>
-                <a:ea typeface="+mn-ea"/>
-                <a:cs typeface="+mn-cs"/>
-              </a:defRPr>
-            </a:lvl3pPr>
-            <a:lvl4pPr marL="1371600" algn="l" defTabSz="914400" rtl="0" eaLnBrk="1" latinLnBrk="0" hangingPunct="1">
-              <a:defRPr sz="1800" kern="1200">
-                <a:solidFill>
-                  <a:schemeClr val="lt1"/>
-                </a:solidFill>
-                <a:latin typeface="+mn-lt"/>
-                <a:ea typeface="+mn-ea"/>
-                <a:cs typeface="+mn-cs"/>
-              </a:defRPr>
-            </a:lvl4pPr>
-            <a:lvl5pPr marL="1828800" algn="l" defTabSz="914400" rtl="0" eaLnBrk="1" latinLnBrk="0" hangingPunct="1">
-              <a:defRPr sz="1800" kern="1200">
-                <a:solidFill>
-                  <a:schemeClr val="lt1"/>
-                </a:solidFill>
-                <a:latin typeface="+mn-lt"/>
-                <a:ea typeface="+mn-ea"/>
-                <a:cs typeface="+mn-cs"/>
-              </a:defRPr>
-            </a:lvl5pPr>
-            <a:lvl6pPr marL="2286000" algn="l" defTabSz="914400" rtl="0" eaLnBrk="1" latinLnBrk="0" hangingPunct="1">
-              <a:defRPr sz="1800" kern="1200">
-                <a:solidFill>
-                  <a:schemeClr val="lt1"/>
-                </a:solidFill>
-                <a:latin typeface="+mn-lt"/>
-                <a:ea typeface="+mn-ea"/>
-                <a:cs typeface="+mn-cs"/>
-              </a:defRPr>
-            </a:lvl6pPr>
-            <a:lvl7pPr marL="2743200" algn="l" defTabSz="914400" rtl="0" eaLnBrk="1" latinLnBrk="0" hangingPunct="1">
-              <a:defRPr sz="1800" kern="1200">
-                <a:solidFill>
-                  <a:schemeClr val="lt1"/>
-                </a:solidFill>
-                <a:latin typeface="+mn-lt"/>
-                <a:ea typeface="+mn-ea"/>
-                <a:cs typeface="+mn-cs"/>
-              </a:defRPr>
-            </a:lvl7pPr>
-            <a:lvl8pPr marL="3200400" algn="l" defTabSz="914400" rtl="0" eaLnBrk="1" latinLnBrk="0" hangingPunct="1">
-              <a:defRPr sz="1800" kern="1200">
-                <a:solidFill>
-                  <a:schemeClr val="lt1"/>
-                </a:solidFill>
-                <a:latin typeface="+mn-lt"/>
-                <a:ea typeface="+mn-ea"/>
-                <a:cs typeface="+mn-cs"/>
-              </a:defRPr>
-            </a:lvl8pPr>
-            <a:lvl9pPr marL="3657600" algn="l" defTabSz="914400" rtl="0" eaLnBrk="1" latinLnBrk="0" hangingPunct="1">
-              <a:defRPr sz="1800" kern="1200">
-                <a:solidFill>
-                  <a:schemeClr val="lt1"/>
-                </a:solidFill>
-                <a:latin typeface="+mn-lt"/>
-                <a:ea typeface="+mn-ea"/>
-                <a:cs typeface="+mn-cs"/>
-              </a:defRPr>
-            </a:lvl9pPr>
-          </a:lstStyle>
-          <a:p>
-            <a:pPr algn="ctr"/>
-            <a:endParaRPr lang="en-US"/>
-          </a:p>
-        </p:txBody>
-      </p:sp>
       <p:pic>
         <p:nvPicPr>
           <p:cNvPr id="4" name="Espace réservé du contenu 3" descr="Une image contenant sol, plein air, poisson, raie&#10;&#10;Le contenu généré par l’IA peut être incorrect.">
@@ -4355,8 +3857,8 @@
         </p:blipFill>
         <p:spPr>
           <a:xfrm>
-            <a:off x="20" y="1282"/>
-            <a:ext cx="12191980" cy="6856718"/>
+            <a:off x="-1523979" y="1283"/>
+            <a:ext cx="12191980" cy="6856719"/>
           </a:xfrm>
           <a:prstGeom prst="rect">
             <a:avLst/>
@@ -4420,7 +3922,7 @@
         </p:blipFill>
         <p:spPr>
           <a:xfrm>
-            <a:off x="6215904" y="811307"/>
+            <a:off x="4691905" y="811307"/>
             <a:ext cx="3047356" cy="5235388"/>
           </a:xfrm>
           <a:prstGeom prst="rect">
@@ -4455,7 +3957,7 @@
         </p:blipFill>
         <p:spPr>
           <a:xfrm rot="16200000">
-            <a:off x="7845517" y="2315885"/>
+            <a:off x="6321518" y="2315887"/>
             <a:ext cx="5235388" cy="2226231"/>
           </a:xfrm>
           <a:prstGeom prst="rect">
@@ -4477,7 +3979,7 @@
         </p:nvSpPr>
         <p:spPr>
           <a:xfrm>
-            <a:off x="561777" y="734918"/>
+            <a:off x="-962222" y="734920"/>
             <a:ext cx="4733925" cy="5262979"/>
           </a:xfrm>
           <a:prstGeom prst="rect">
@@ -4491,7 +3993,7 @@
           </a:bodyPr>
           <a:lstStyle/>
           <a:p>
-            <a:pPr marL="457200" indent="-457200">
+            <a:pPr marL="457189" indent="-457189">
               <a:buFont typeface="Arial" panose="020B0604020202020204" pitchFamily="34" charset="0"/>
               <a:buChar char="•"/>
             </a:pPr>
@@ -4509,7 +4011,7 @@
             </a:r>
           </a:p>
           <a:p>
-            <a:pPr marL="457200" indent="-457200">
+            <a:pPr marL="457189" indent="-457189">
               <a:buFont typeface="Arial" panose="020B0604020202020204" pitchFamily="34" charset="0"/>
               <a:buChar char="•"/>
             </a:pPr>
@@ -4518,7 +4020,7 @@
             </a:endParaRPr>
           </a:p>
           <a:p>
-            <a:pPr marL="457200" indent="-457200">
+            <a:pPr marL="457189" indent="-457189">
               <a:buFont typeface="Arial" panose="020B0604020202020204" pitchFamily="34" charset="0"/>
               <a:buChar char="•"/>
             </a:pPr>
@@ -4536,7 +4038,7 @@
             </a:r>
           </a:p>
           <a:p>
-            <a:pPr marL="457200" indent="-457200">
+            <a:pPr marL="457189" indent="-457189">
               <a:buFont typeface="Arial" panose="020B0604020202020204" pitchFamily="34" charset="0"/>
               <a:buChar char="•"/>
             </a:pPr>
@@ -4545,7 +4047,7 @@
             </a:endParaRPr>
           </a:p>
           <a:p>
-            <a:pPr marL="457200" indent="-457200">
+            <a:pPr marL="457189" indent="-457189">
               <a:buFont typeface="Arial" panose="020B0604020202020204" pitchFamily="34" charset="0"/>
               <a:buChar char="•"/>
             </a:pPr>
@@ -4563,7 +4065,7 @@
             </a:r>
           </a:p>
           <a:p>
-            <a:pPr marL="457200" indent="-457200">
+            <a:pPr marL="457189" indent="-457189">
               <a:buFont typeface="Arial" panose="020B0604020202020204" pitchFamily="34" charset="0"/>
               <a:buChar char="•"/>
             </a:pPr>
@@ -4572,7 +4074,7 @@
             </a:endParaRPr>
           </a:p>
           <a:p>
-            <a:pPr marL="457200" indent="-457200">
+            <a:pPr marL="457189" indent="-457189">
               <a:buFont typeface="Arial" panose="020B0604020202020204" pitchFamily="34" charset="0"/>
               <a:buChar char="•"/>
             </a:pPr>
@@ -4590,7 +4092,7 @@
             </a:r>
           </a:p>
           <a:p>
-            <a:pPr marL="457200" indent="-457200">
+            <a:pPr marL="457189" indent="-457189">
               <a:buFont typeface="Arial" panose="020B0604020202020204" pitchFamily="34" charset="0"/>
               <a:buChar char="•"/>
             </a:pPr>
@@ -4599,7 +4101,7 @@
             </a:endParaRPr>
           </a:p>
           <a:p>
-            <a:pPr marL="457200" indent="-457200">
+            <a:pPr marL="457189" indent="-457189">
               <a:buFont typeface="Arial" panose="020B0604020202020204" pitchFamily="34" charset="0"/>
               <a:buChar char="•"/>
             </a:pPr>
@@ -4617,7 +4119,7 @@
             </a:r>
           </a:p>
           <a:p>
-            <a:pPr marL="457200" indent="-457200">
+            <a:pPr marL="457189" indent="-457189">
               <a:buFont typeface="Arial" panose="020B0604020202020204" pitchFamily="34" charset="0"/>
               <a:buChar char="•"/>
             </a:pPr>
@@ -4626,7 +4128,7 @@
             </a:endParaRPr>
           </a:p>
           <a:p>
-            <a:pPr marL="457200" indent="-457200">
+            <a:pPr marL="457189" indent="-457189">
               <a:buFont typeface="Arial" panose="020B0604020202020204" pitchFamily="34" charset="0"/>
               <a:buChar char="•"/>
             </a:pPr>
@@ -4702,7 +4204,7 @@
         </p:blipFill>
         <p:spPr>
           <a:xfrm>
-            <a:off x="8520954" y="811306"/>
+            <a:off x="6996955" y="811307"/>
             <a:ext cx="3047356" cy="5235388"/>
           </a:xfrm>
           <a:prstGeom prst="rect">
@@ -4724,7 +4226,7 @@
         </p:nvSpPr>
         <p:spPr>
           <a:xfrm>
-            <a:off x="661790" y="1125443"/>
+            <a:off x="-862209" y="1125443"/>
             <a:ext cx="6982023" cy="4339650"/>
           </a:xfrm>
           <a:prstGeom prst="rect">
@@ -4844,7 +4346,7 @@
         </p:nvSpPr>
         <p:spPr>
           <a:xfrm>
-            <a:off x="661790" y="1125443"/>
+            <a:off x="-862209" y="1125443"/>
             <a:ext cx="6982023" cy="3724096"/>
           </a:xfrm>
           <a:prstGeom prst="rect">
@@ -4941,7 +4443,7 @@
         </p:blipFill>
         <p:spPr>
           <a:xfrm rot="16200000">
-            <a:off x="7845517" y="2315885"/>
+            <a:off x="6321518" y="2315887"/>
             <a:ext cx="5235388" cy="2226231"/>
           </a:xfrm>
           <a:prstGeom prst="rect">
@@ -4965,7 +4467,7 @@
 <file path=ppt/theme/theme1.xml><?xml version="1.0" encoding="utf-8"?>
 <a:theme xmlns:a="http://schemas.openxmlformats.org/drawingml/2006/main" name="Thème Office">
   <a:themeElements>
-    <a:clrScheme name="Office">
+    <a:clrScheme name="Thème Office">
       <a:dk1>
         <a:sysClr val="windowText" lastClr="000000"/>
       </a:dk1>
@@ -5003,7 +4505,7 @@
         <a:srgbClr val="96607D"/>
       </a:folHlink>
     </a:clrScheme>
-    <a:fontScheme name="Office">
+    <a:fontScheme name="Thème Office">
       <a:majorFont>
         <a:latin typeface="Aptos Display" panose="02110004020202020204"/>
         <a:ea typeface=""/>
@@ -5109,7 +4611,7 @@
         <a:font script="Tfng" typeface="Ebrima"/>
       </a:minorFont>
     </a:fontScheme>
-    <a:fmtScheme name="Office">
+    <a:fmtScheme name="Thème Office">
       <a:fillStyleLst>
         <a:solidFill>
           <a:schemeClr val="phClr"/>

</xml_diff>